<commit_message>
Cruze now omniscient with memory + drag & drop
</commit_message>
<xml_diff>
--- a/JDE_Mission_Control_Dashboard_Guide.pptx
+++ b/JDE_Mission_Control_Dashboard_Guide.pptx
@@ -4,22 +4,25 @@
   <p:sldMasterIdLst>
     <p:sldMasterId id="2147483648" r:id="rId1"/>
   </p:sldMasterIdLst>
+  <p:notesMasterIdLst>
+    <p:notesMasterId r:id="rId15"/>
+  </p:notesMasterIdLst>
   <p:sldIdLst>
-    <p:sldId id="256" r:id="rId7"/>
-    <p:sldId id="257" r:id="rId9"/>
-    <p:sldId id="258" r:id="rId10"/>
-    <p:sldId id="259" r:id="rId11"/>
-    <p:sldId id="260" r:id="rId12"/>
-    <p:sldId id="261" r:id="rId13"/>
-    <p:sldId id="262" r:id="rId14"/>
-    <p:sldId id="263" r:id="rId15"/>
-    <p:sldId id="264" r:id="rId16"/>
-    <p:sldId id="265" r:id="rId17"/>
-    <p:sldId id="266" r:id="rId18"/>
-    <p:sldId id="267" r:id="rId19"/>
-    <p:sldId id="268" r:id="rId20"/>
+    <p:sldId id="256" r:id="rId2"/>
+    <p:sldId id="257" r:id="rId3"/>
+    <p:sldId id="258" r:id="rId4"/>
+    <p:sldId id="259" r:id="rId5"/>
+    <p:sldId id="260" r:id="rId6"/>
+    <p:sldId id="261" r:id="rId7"/>
+    <p:sldId id="262" r:id="rId8"/>
+    <p:sldId id="263" r:id="rId9"/>
+    <p:sldId id="264" r:id="rId10"/>
+    <p:sldId id="265" r:id="rId11"/>
+    <p:sldId id="266" r:id="rId12"/>
+    <p:sldId id="267" r:id="rId13"/>
+    <p:sldId id="268" r:id="rId14"/>
   </p:sldIdLst>
-  <p:sldSz cx="12191695" cy="6858000" type="screen4x3"/>
+  <p:sldSz cx="12192000" cy="6858000"/>
   <p:notesSz cx="6858000" cy="9144000"/>
   <p:defaultTextStyle>
     <a:defPPr>
@@ -116,11 +119,27 @@
       </a:defRPr>
     </a:lvl9pPr>
   </p:defaultTextStyle>
+  <p:extLst>
+    <p:ext uri="{EFAFB233-063F-42B5-8137-9DF3F51BA10A}">
+      <p15:sldGuideLst xmlns:p15="http://schemas.microsoft.com/office/powerpoint/2012/main">
+        <p15:guide id="1" orient="horz" pos="2160">
+          <p15:clr>
+            <a:srgbClr val="A4A3A4"/>
+          </p15:clr>
+        </p15:guide>
+        <p15:guide id="2" pos="2880">
+          <p15:clr>
+            <a:srgbClr val="A4A3A4"/>
+          </p15:clr>
+        </p15:guide>
+      </p15:sldGuideLst>
+    </p:ext>
+  </p:extLst>
 </p:presentation>
 </file>
 
 <file path=ppt/notesMasters/notesMaster1.xml><?xml version="1.0" encoding="utf-8"?>
-<p:notesMaster xmlns:a="http://schemas.openxmlformats.org/drawingml/2006/main" xmlns:p="http://schemas.openxmlformats.org/presentationml/2006/main" xmlns:r="http://schemas.openxmlformats.org/officeDocument/2006/relationships">
+<p:notesMaster xmlns:a="http://schemas.openxmlformats.org/drawingml/2006/main" xmlns:r="http://schemas.openxmlformats.org/officeDocument/2006/relationships" xmlns:p="http://schemas.openxmlformats.org/presentationml/2006/main">
   <p:cSld>
     <p:bg>
       <p:bgRef idx="1001">
@@ -141,241 +160,16 @@
           <a:chExt cx="0" cy="0"/>
         </a:xfrm>
       </p:grpSpPr>
-      <p:sp>
-        <p:nvSpPr>
-          <p:cNvPr id="2" name="Header Placeholder 1"/>
-          <p:cNvSpPr>
-            <a:spLocks noGrp="1"/>
-          </p:cNvSpPr>
-          <p:nvPr>
-            <p:ph type="hdr" sz="quarter"/>
-          </p:nvPr>
-        </p:nvSpPr>
-        <p:spPr>
-          <a:xfrm>
-            <a:off x="0" y="0"/>
-            <a:ext cx="2971800" cy="457200"/>
-          </a:xfrm>
-          <a:prstGeom prst="rect">
-            <a:avLst/>
-          </a:prstGeom>
-        </p:spPr>
-        <p:txBody>
-          <a:bodyPr vert="horz" lIns="91440" tIns="45720" rIns="91440" bIns="45720" rtlCol="0"/>
-          <a:lstStyle>
-            <a:lvl1pPr algn="l">
-              <a:defRPr sz="1200"/>
-            </a:lvl1pPr>
-          </a:lstStyle>
-          <a:p>
-            <a:endParaRPr lang="en-US"/>
-          </a:p>
-        </p:txBody>
-      </p:sp>
-      <p:sp>
-        <p:nvSpPr>
-          <p:cNvPr id="3" name="Date Placeholder 2"/>
-          <p:cNvSpPr>
-            <a:spLocks noGrp="1"/>
-          </p:cNvSpPr>
-          <p:nvPr>
-            <p:ph type="dt" idx="1"/>
-          </p:nvPr>
-        </p:nvSpPr>
-        <p:spPr>
-          <a:xfrm>
-            <a:off x="3884613" y="0"/>
-            <a:ext cx="2971800" cy="457200"/>
-          </a:xfrm>
-          <a:prstGeom prst="rect">
-            <a:avLst/>
-          </a:prstGeom>
-        </p:spPr>
-        <p:txBody>
-          <a:bodyPr vert="horz" lIns="91440" tIns="45720" rIns="91440" bIns="45720" rtlCol="0"/>
-          <a:lstStyle>
-            <a:lvl1pPr algn="r">
-              <a:defRPr sz="1200"/>
-            </a:lvl1pPr>
-          </a:lstStyle>
-          <a:p>
-            <a:fld id="{0F89C1C7-3DCD-1040-A9CF-14679D8B5DDD}" type="datetimeFigureOut">
-              <a:rPr lang="en-US" smtClean="0"/>
-              <a:t>10/17/16</a:t>
-            </a:fld>
-            <a:endParaRPr lang="en-US"/>
-          </a:p>
-        </p:txBody>
-      </p:sp>
-      <p:sp>
-        <p:nvSpPr>
-          <p:cNvPr id="4" name="Slide Image Placeholder 3"/>
-          <p:cNvSpPr>
-            <a:spLocks noGrp="1" noRot="1" noChangeAspect="1"/>
-          </p:cNvSpPr>
-          <p:nvPr>
-            <p:ph type="sldImg" idx="2"/>
-          </p:nvPr>
-        </p:nvSpPr>
-        <p:spPr>
-          <a:xfrm>
-            <a:off x="1143000" y="685800"/>
-            <a:ext cx="4572000" cy="3429000"/>
-          </a:xfrm>
-          <a:prstGeom prst="rect">
-            <a:avLst/>
-          </a:prstGeom>
-          <a:noFill/>
-          <a:ln w="12700">
-            <a:solidFill>
-              <a:prstClr val="black"/>
-            </a:solidFill>
-          </a:ln>
-        </p:spPr>
-        <p:txBody>
-          <a:bodyPr vert="horz" lIns="91440" tIns="45720" rIns="91440" bIns="45720" rtlCol="0" anchor="ctr"/>
-          <a:lstStyle/>
-          <a:p>
-            <a:endParaRPr lang="en-US"/>
-          </a:p>
-        </p:txBody>
-      </p:sp>
-      <p:sp>
-        <p:nvSpPr>
-          <p:cNvPr id="5" name="Notes Placeholder 4"/>
-          <p:cNvSpPr>
-            <a:spLocks noGrp="1"/>
-          </p:cNvSpPr>
-          <p:nvPr>
-            <p:ph type="body" sz="quarter" idx="3"/>
-          </p:nvPr>
-        </p:nvSpPr>
-        <p:spPr>
-          <a:xfrm>
-            <a:off x="685800" y="4343400"/>
-            <a:ext cx="5486400" cy="4114800"/>
-          </a:xfrm>
-          <a:prstGeom prst="rect">
-            <a:avLst/>
-          </a:prstGeom>
-        </p:spPr>
-        <p:txBody>
-          <a:bodyPr vert="horz" lIns="91440" tIns="45720" rIns="91440" bIns="45720" rtlCol="0"/>
-          <a:lstStyle/>
-          <a:p>
-            <a:pPr lvl="0"/>
-            <a:r>
-              <a:rPr lang="en-US" smtClean="0"/>
-              <a:t>Click to edit Master text styles</a:t>
-            </a:r>
-          </a:p>
-          <a:p>
-            <a:pPr lvl="1"/>
-            <a:r>
-              <a:rPr lang="en-US" smtClean="0"/>
-              <a:t>Second level</a:t>
-            </a:r>
-          </a:p>
-          <a:p>
-            <a:pPr lvl="2"/>
-            <a:r>
-              <a:rPr lang="en-US" smtClean="0"/>
-              <a:t>Third level</a:t>
-            </a:r>
-          </a:p>
-          <a:p>
-            <a:pPr lvl="3"/>
-            <a:r>
-              <a:rPr lang="en-US" smtClean="0"/>
-              <a:t>Fourth level</a:t>
-            </a:r>
-          </a:p>
-          <a:p>
-            <a:pPr lvl="4"/>
-            <a:r>
-              <a:rPr lang="en-US" smtClean="0"/>
-              <a:t>Fifth level</a:t>
-            </a:r>
-            <a:endParaRPr lang="en-US"/>
-          </a:p>
-        </p:txBody>
-      </p:sp>
-      <p:sp>
-        <p:nvSpPr>
-          <p:cNvPr id="6" name="Footer Placeholder 5"/>
-          <p:cNvSpPr>
-            <a:spLocks noGrp="1"/>
-          </p:cNvSpPr>
-          <p:nvPr>
-            <p:ph type="ftr" sz="quarter" idx="4"/>
-          </p:nvPr>
-        </p:nvSpPr>
-        <p:spPr>
-          <a:xfrm>
-            <a:off x="0" y="8685213"/>
-            <a:ext cx="2971800" cy="457200"/>
-          </a:xfrm>
-          <a:prstGeom prst="rect">
-            <a:avLst/>
-          </a:prstGeom>
-        </p:spPr>
-        <p:txBody>
-          <a:bodyPr vert="horz" lIns="91440" tIns="45720" rIns="91440" bIns="45720" rtlCol="0" anchor="b"/>
-          <a:lstStyle>
-            <a:lvl1pPr algn="l">
-              <a:defRPr sz="1200"/>
-            </a:lvl1pPr>
-          </a:lstStyle>
-          <a:p>
-            <a:endParaRPr lang="en-US"/>
-          </a:p>
-        </p:txBody>
-      </p:sp>
-      <p:sp>
-        <p:nvSpPr>
-          <p:cNvPr id="7" name="Slide Number Placeholder 6"/>
-          <p:cNvSpPr>
-            <a:spLocks noGrp="1"/>
-          </p:cNvSpPr>
-          <p:nvPr>
-            <p:ph type="sldNum" sz="quarter" idx="5"/>
-          </p:nvPr>
-        </p:nvSpPr>
-        <p:spPr>
-          <a:xfrm>
-            <a:off x="3884613" y="8685213"/>
-            <a:ext cx="2971800" cy="457200"/>
-          </a:xfrm>
-          <a:prstGeom prst="rect">
-            <a:avLst/>
-          </a:prstGeom>
-        </p:spPr>
-        <p:txBody>
-          <a:bodyPr vert="horz" lIns="91440" tIns="45720" rIns="91440" bIns="45720" rtlCol="0" anchor="b"/>
-          <a:lstStyle>
-            <a:lvl1pPr algn="r">
-              <a:defRPr sz="1200"/>
-            </a:lvl1pPr>
-          </a:lstStyle>
-          <a:p>
-            <a:fld id="{BB5E49A5-4136-284D-997B-48E1D791AD67}" type="slidenum">
-              <a:rPr lang="en-US" smtClean="0"/>
-              <a:t>‹#›</a:t>
-            </a:fld>
-            <a:endParaRPr lang="en-US"/>
-          </a:p>
-        </p:txBody>
-      </p:sp>
     </p:spTree>
     <p:extLst>
       <p:ext uri="{BB962C8B-B14F-4D97-AF65-F5344CB8AC3E}">
-        <p14:creationId xmlns:p14="http://schemas.microsoft.com/office/powerpoint/2010/main" val="2623252185"/>
+        <p14:creationId xmlns:p14="http://schemas.microsoft.com/office/powerpoint/2010/main" val="1143609277"/>
       </p:ext>
     </p:extLst>
   </p:cSld>
   <p:clrMap bg1="lt1" tx1="dk1" bg2="lt2" tx2="dk2" accent1="accent1" accent2="accent2" accent3="accent3" accent4="accent4" accent5="accent5" accent6="accent6" hlink="hlink" folHlink="folHlink"/>
   <p:notesStyle>
-    <a:lvl1pPr marL="0" algn="l" defTabSz="457200" rtl="0" eaLnBrk="1" latinLnBrk="0" hangingPunct="1">
+    <a:lvl1pPr marL="0" algn="l" defTabSz="914400" rtl="0" eaLnBrk="1" latinLnBrk="0" hangingPunct="1">
       <a:defRPr sz="1200" kern="1200">
         <a:solidFill>
           <a:schemeClr val="tx1"/>
@@ -385,7 +179,7 @@
         <a:cs typeface="+mn-cs"/>
       </a:defRPr>
     </a:lvl1pPr>
-    <a:lvl2pPr marL="457200" algn="l" defTabSz="457200" rtl="0" eaLnBrk="1" latinLnBrk="0" hangingPunct="1">
+    <a:lvl2pPr marL="457200" algn="l" defTabSz="914400" rtl="0" eaLnBrk="1" latinLnBrk="0" hangingPunct="1">
       <a:defRPr sz="1200" kern="1200">
         <a:solidFill>
           <a:schemeClr val="tx1"/>
@@ -395,7 +189,7 @@
         <a:cs typeface="+mn-cs"/>
       </a:defRPr>
     </a:lvl2pPr>
-    <a:lvl3pPr marL="914400" algn="l" defTabSz="457200" rtl="0" eaLnBrk="1" latinLnBrk="0" hangingPunct="1">
+    <a:lvl3pPr marL="914400" algn="l" defTabSz="914400" rtl="0" eaLnBrk="1" latinLnBrk="0" hangingPunct="1">
       <a:defRPr sz="1200" kern="1200">
         <a:solidFill>
           <a:schemeClr val="tx1"/>
@@ -405,7 +199,7 @@
         <a:cs typeface="+mn-cs"/>
       </a:defRPr>
     </a:lvl3pPr>
-    <a:lvl4pPr marL="1371600" algn="l" defTabSz="457200" rtl="0" eaLnBrk="1" latinLnBrk="0" hangingPunct="1">
+    <a:lvl4pPr marL="1371600" algn="l" defTabSz="914400" rtl="0" eaLnBrk="1" latinLnBrk="0" hangingPunct="1">
       <a:defRPr sz="1200" kern="1200">
         <a:solidFill>
           <a:schemeClr val="tx1"/>
@@ -415,7 +209,7 @@
         <a:cs typeface="+mn-cs"/>
       </a:defRPr>
     </a:lvl4pPr>
-    <a:lvl5pPr marL="1828800" algn="l" defTabSz="457200" rtl="0" eaLnBrk="1" latinLnBrk="0" hangingPunct="1">
+    <a:lvl5pPr marL="1828800" algn="l" defTabSz="914400" rtl="0" eaLnBrk="1" latinLnBrk="0" hangingPunct="1">
       <a:defRPr sz="1200" kern="1200">
         <a:solidFill>
           <a:schemeClr val="tx1"/>
@@ -425,7 +219,7 @@
         <a:cs typeface="+mn-cs"/>
       </a:defRPr>
     </a:lvl5pPr>
-    <a:lvl6pPr marL="2286000" algn="l" defTabSz="457200" rtl="0" eaLnBrk="1" latinLnBrk="0" hangingPunct="1">
+    <a:lvl6pPr marL="2286000" algn="l" defTabSz="914400" rtl="0" eaLnBrk="1" latinLnBrk="0" hangingPunct="1">
       <a:defRPr sz="1200" kern="1200">
         <a:solidFill>
           <a:schemeClr val="tx1"/>
@@ -435,7 +229,7 @@
         <a:cs typeface="+mn-cs"/>
       </a:defRPr>
     </a:lvl6pPr>
-    <a:lvl7pPr marL="2743200" algn="l" defTabSz="457200" rtl="0" eaLnBrk="1" latinLnBrk="0" hangingPunct="1">
+    <a:lvl7pPr marL="2743200" algn="l" defTabSz="914400" rtl="0" eaLnBrk="1" latinLnBrk="0" hangingPunct="1">
       <a:defRPr sz="1200" kern="1200">
         <a:solidFill>
           <a:schemeClr val="tx1"/>
@@ -445,7 +239,7 @@
         <a:cs typeface="+mn-cs"/>
       </a:defRPr>
     </a:lvl7pPr>
-    <a:lvl8pPr marL="3200400" algn="l" defTabSz="457200" rtl="0" eaLnBrk="1" latinLnBrk="0" hangingPunct="1">
+    <a:lvl8pPr marL="3200400" algn="l" defTabSz="914400" rtl="0" eaLnBrk="1" latinLnBrk="0" hangingPunct="1">
       <a:defRPr sz="1200" kern="1200">
         <a:solidFill>
           <a:schemeClr val="tx1"/>
@@ -455,7 +249,7 @@
         <a:cs typeface="+mn-cs"/>
       </a:defRPr>
     </a:lvl8pPr>
-    <a:lvl9pPr marL="3657600" algn="l" defTabSz="457200" rtl="0" eaLnBrk="1" latinLnBrk="0" hangingPunct="1">
+    <a:lvl9pPr marL="3657600" algn="l" defTabSz="914400" rtl="0" eaLnBrk="1" latinLnBrk="0" hangingPunct="1">
       <a:defRPr sz="1200" kern="1200">
         <a:solidFill>
           <a:schemeClr val="tx1"/>
@@ -470,7 +264,7 @@
 </file>
 
 <file path=ppt/notesSlides/notesSlide1.xml><?xml version="1.0" encoding="utf-8"?>
-<p:notes xmlns:a="http://schemas.openxmlformats.org/drawingml/2006/main" xmlns:p="http://schemas.openxmlformats.org/presentationml/2006/main" xmlns:r="http://schemas.openxmlformats.org/officeDocument/2006/relationships">
+<p:notes xmlns:a="http://schemas.openxmlformats.org/drawingml/2006/main" xmlns:r="http://schemas.openxmlformats.org/officeDocument/2006/relationships" xmlns:p="http://schemas.openxmlformats.org/presentationml/2006/main">
   <p:cSld>
     <p:spTree>
       <p:nvGrpSpPr>
@@ -490,7 +284,7 @@
         <p:nvSpPr>
           <p:cNvPr id="2" name="Slide Image Placeholder 1"/>
           <p:cNvSpPr>
-            <a:spLocks noGrp="1"/>
+            <a:spLocks noGrp="1" noRot="1" noChangeAspect="1"/>
           </p:cNvSpPr>
           <p:nvPr>
             <p:ph type="sldImg" idx="2"/>
@@ -505,7 +299,7 @@
             <a:spLocks noGrp="1"/>
           </p:cNvSpPr>
           <p:nvPr>
-            <p:ph type="body" idx="3" sz="quarter"/>
+            <p:ph type="body" sz="quarter" idx="3"/>
           </p:nvPr>
         </p:nvSpPr>
         <p:spPr/>
@@ -526,7 +320,7 @@
             <a:spLocks noGrp="1"/>
           </p:cNvSpPr>
           <p:nvPr>
-            <p:ph type="sldNum" idx="5" sz="quarter"/>
+            <p:ph type="sldNum" sz="quarter" idx="5"/>
           </p:nvPr>
         </p:nvSpPr>
         <p:spPr/>
@@ -540,7 +334,7 @@
 </file>
 
 <file path=ppt/notesSlides/notesSlide10.xml><?xml version="1.0" encoding="utf-8"?>
-<p:notes xmlns:a="http://schemas.openxmlformats.org/drawingml/2006/main" xmlns:p="http://schemas.openxmlformats.org/presentationml/2006/main" xmlns:r="http://schemas.openxmlformats.org/officeDocument/2006/relationships">
+<p:notes xmlns:a="http://schemas.openxmlformats.org/drawingml/2006/main" xmlns:r="http://schemas.openxmlformats.org/officeDocument/2006/relationships" xmlns:p="http://schemas.openxmlformats.org/presentationml/2006/main">
   <p:cSld>
     <p:spTree>
       <p:nvGrpSpPr>
@@ -560,7 +354,7 @@
         <p:nvSpPr>
           <p:cNvPr id="2" name="Slide Image Placeholder 1"/>
           <p:cNvSpPr>
-            <a:spLocks noGrp="1"/>
+            <a:spLocks noGrp="1" noRot="1" noChangeAspect="1"/>
           </p:cNvSpPr>
           <p:nvPr>
             <p:ph type="sldImg" idx="2"/>
@@ -575,7 +369,7 @@
             <a:spLocks noGrp="1"/>
           </p:cNvSpPr>
           <p:nvPr>
-            <p:ph type="body" idx="3" sz="quarter"/>
+            <p:ph type="body" sz="quarter" idx="3"/>
           </p:nvPr>
         </p:nvSpPr>
         <p:spPr/>
@@ -596,7 +390,7 @@
             <a:spLocks noGrp="1"/>
           </p:cNvSpPr>
           <p:nvPr>
-            <p:ph type="sldNum" idx="5" sz="quarter"/>
+            <p:ph type="sldNum" sz="quarter" idx="5"/>
           </p:nvPr>
         </p:nvSpPr>
         <p:spPr/>
@@ -610,7 +404,7 @@
 </file>
 
 <file path=ppt/notesSlides/notesSlide11.xml><?xml version="1.0" encoding="utf-8"?>
-<p:notes xmlns:a="http://schemas.openxmlformats.org/drawingml/2006/main" xmlns:p="http://schemas.openxmlformats.org/presentationml/2006/main" xmlns:r="http://schemas.openxmlformats.org/officeDocument/2006/relationships">
+<p:notes xmlns:a="http://schemas.openxmlformats.org/drawingml/2006/main" xmlns:r="http://schemas.openxmlformats.org/officeDocument/2006/relationships" xmlns:p="http://schemas.openxmlformats.org/presentationml/2006/main">
   <p:cSld>
     <p:spTree>
       <p:nvGrpSpPr>
@@ -630,7 +424,7 @@
         <p:nvSpPr>
           <p:cNvPr id="2" name="Slide Image Placeholder 1"/>
           <p:cNvSpPr>
-            <a:spLocks noGrp="1"/>
+            <a:spLocks noGrp="1" noRot="1" noChangeAspect="1"/>
           </p:cNvSpPr>
           <p:nvPr>
             <p:ph type="sldImg" idx="2"/>
@@ -645,7 +439,7 @@
             <a:spLocks noGrp="1"/>
           </p:cNvSpPr>
           <p:nvPr>
-            <p:ph type="body" idx="3" sz="quarter"/>
+            <p:ph type="body" sz="quarter" idx="3"/>
           </p:nvPr>
         </p:nvSpPr>
         <p:spPr/>
@@ -666,7 +460,7 @@
             <a:spLocks noGrp="1"/>
           </p:cNvSpPr>
           <p:nvPr>
-            <p:ph type="sldNum" idx="5" sz="quarter"/>
+            <p:ph type="sldNum" sz="quarter" idx="5"/>
           </p:nvPr>
         </p:nvSpPr>
         <p:spPr/>
@@ -680,7 +474,7 @@
 </file>
 
 <file path=ppt/notesSlides/notesSlide12.xml><?xml version="1.0" encoding="utf-8"?>
-<p:notes xmlns:a="http://schemas.openxmlformats.org/drawingml/2006/main" xmlns:p="http://schemas.openxmlformats.org/presentationml/2006/main" xmlns:r="http://schemas.openxmlformats.org/officeDocument/2006/relationships">
+<p:notes xmlns:a="http://schemas.openxmlformats.org/drawingml/2006/main" xmlns:r="http://schemas.openxmlformats.org/officeDocument/2006/relationships" xmlns:p="http://schemas.openxmlformats.org/presentationml/2006/main">
   <p:cSld>
     <p:spTree>
       <p:nvGrpSpPr>
@@ -700,7 +494,7 @@
         <p:nvSpPr>
           <p:cNvPr id="2" name="Slide Image Placeholder 1"/>
           <p:cNvSpPr>
-            <a:spLocks noGrp="1"/>
+            <a:spLocks noGrp="1" noRot="1" noChangeAspect="1"/>
           </p:cNvSpPr>
           <p:nvPr>
             <p:ph type="sldImg" idx="2"/>
@@ -715,7 +509,7 @@
             <a:spLocks noGrp="1"/>
           </p:cNvSpPr>
           <p:nvPr>
-            <p:ph type="body" idx="3" sz="quarter"/>
+            <p:ph type="body" sz="quarter" idx="3"/>
           </p:nvPr>
         </p:nvSpPr>
         <p:spPr/>
@@ -736,7 +530,7 @@
             <a:spLocks noGrp="1"/>
           </p:cNvSpPr>
           <p:nvPr>
-            <p:ph type="sldNum" idx="5" sz="quarter"/>
+            <p:ph type="sldNum" sz="quarter" idx="5"/>
           </p:nvPr>
         </p:nvSpPr>
         <p:spPr/>
@@ -750,7 +544,7 @@
 </file>
 
 <file path=ppt/notesSlides/notesSlide13.xml><?xml version="1.0" encoding="utf-8"?>
-<p:notes xmlns:a="http://schemas.openxmlformats.org/drawingml/2006/main" xmlns:p="http://schemas.openxmlformats.org/presentationml/2006/main" xmlns:r="http://schemas.openxmlformats.org/officeDocument/2006/relationships">
+<p:notes xmlns:a="http://schemas.openxmlformats.org/drawingml/2006/main" xmlns:r="http://schemas.openxmlformats.org/officeDocument/2006/relationships" xmlns:p="http://schemas.openxmlformats.org/presentationml/2006/main">
   <p:cSld>
     <p:spTree>
       <p:nvGrpSpPr>
@@ -770,7 +564,7 @@
         <p:nvSpPr>
           <p:cNvPr id="2" name="Slide Image Placeholder 1"/>
           <p:cNvSpPr>
-            <a:spLocks noGrp="1"/>
+            <a:spLocks noGrp="1" noRot="1" noChangeAspect="1"/>
           </p:cNvSpPr>
           <p:nvPr>
             <p:ph type="sldImg" idx="2"/>
@@ -785,7 +579,7 @@
             <a:spLocks noGrp="1"/>
           </p:cNvSpPr>
           <p:nvPr>
-            <p:ph type="body" idx="3" sz="quarter"/>
+            <p:ph type="body" sz="quarter" idx="3"/>
           </p:nvPr>
         </p:nvSpPr>
         <p:spPr/>
@@ -806,7 +600,7 @@
             <a:spLocks noGrp="1"/>
           </p:cNvSpPr>
           <p:nvPr>
-            <p:ph type="sldNum" idx="5" sz="quarter"/>
+            <p:ph type="sldNum" sz="quarter" idx="5"/>
           </p:nvPr>
         </p:nvSpPr>
         <p:spPr/>
@@ -820,7 +614,7 @@
 </file>
 
 <file path=ppt/notesSlides/notesSlide2.xml><?xml version="1.0" encoding="utf-8"?>
-<p:notes xmlns:a="http://schemas.openxmlformats.org/drawingml/2006/main" xmlns:p="http://schemas.openxmlformats.org/presentationml/2006/main" xmlns:r="http://schemas.openxmlformats.org/officeDocument/2006/relationships">
+<p:notes xmlns:a="http://schemas.openxmlformats.org/drawingml/2006/main" xmlns:r="http://schemas.openxmlformats.org/officeDocument/2006/relationships" xmlns:p="http://schemas.openxmlformats.org/presentationml/2006/main">
   <p:cSld>
     <p:spTree>
       <p:nvGrpSpPr>
@@ -840,7 +634,7 @@
         <p:nvSpPr>
           <p:cNvPr id="2" name="Slide Image Placeholder 1"/>
           <p:cNvSpPr>
-            <a:spLocks noGrp="1"/>
+            <a:spLocks noGrp="1" noRot="1" noChangeAspect="1"/>
           </p:cNvSpPr>
           <p:nvPr>
             <p:ph type="sldImg" idx="2"/>
@@ -855,7 +649,7 @@
             <a:spLocks noGrp="1"/>
           </p:cNvSpPr>
           <p:nvPr>
-            <p:ph type="body" idx="3" sz="quarter"/>
+            <p:ph type="body" sz="quarter" idx="3"/>
           </p:nvPr>
         </p:nvSpPr>
         <p:spPr/>
@@ -876,7 +670,7 @@
             <a:spLocks noGrp="1"/>
           </p:cNvSpPr>
           <p:nvPr>
-            <p:ph type="sldNum" idx="5" sz="quarter"/>
+            <p:ph type="sldNum" sz="quarter" idx="5"/>
           </p:nvPr>
         </p:nvSpPr>
         <p:spPr/>
@@ -890,7 +684,7 @@
 </file>
 
 <file path=ppt/notesSlides/notesSlide3.xml><?xml version="1.0" encoding="utf-8"?>
-<p:notes xmlns:a="http://schemas.openxmlformats.org/drawingml/2006/main" xmlns:p="http://schemas.openxmlformats.org/presentationml/2006/main" xmlns:r="http://schemas.openxmlformats.org/officeDocument/2006/relationships">
+<p:notes xmlns:a="http://schemas.openxmlformats.org/drawingml/2006/main" xmlns:r="http://schemas.openxmlformats.org/officeDocument/2006/relationships" xmlns:p="http://schemas.openxmlformats.org/presentationml/2006/main">
   <p:cSld>
     <p:spTree>
       <p:nvGrpSpPr>
@@ -910,7 +704,7 @@
         <p:nvSpPr>
           <p:cNvPr id="2" name="Slide Image Placeholder 1"/>
           <p:cNvSpPr>
-            <a:spLocks noGrp="1"/>
+            <a:spLocks noGrp="1" noRot="1" noChangeAspect="1"/>
           </p:cNvSpPr>
           <p:nvPr>
             <p:ph type="sldImg" idx="2"/>
@@ -925,7 +719,7 @@
             <a:spLocks noGrp="1"/>
           </p:cNvSpPr>
           <p:nvPr>
-            <p:ph type="body" idx="3" sz="quarter"/>
+            <p:ph type="body" sz="quarter" idx="3"/>
           </p:nvPr>
         </p:nvSpPr>
         <p:spPr/>
@@ -946,7 +740,7 @@
             <a:spLocks noGrp="1"/>
           </p:cNvSpPr>
           <p:nvPr>
-            <p:ph type="sldNum" idx="5" sz="quarter"/>
+            <p:ph type="sldNum" sz="quarter" idx="5"/>
           </p:nvPr>
         </p:nvSpPr>
         <p:spPr/>
@@ -960,7 +754,7 @@
 </file>
 
 <file path=ppt/notesSlides/notesSlide4.xml><?xml version="1.0" encoding="utf-8"?>
-<p:notes xmlns:a="http://schemas.openxmlformats.org/drawingml/2006/main" xmlns:p="http://schemas.openxmlformats.org/presentationml/2006/main" xmlns:r="http://schemas.openxmlformats.org/officeDocument/2006/relationships">
+<p:notes xmlns:a="http://schemas.openxmlformats.org/drawingml/2006/main" xmlns:r="http://schemas.openxmlformats.org/officeDocument/2006/relationships" xmlns:p="http://schemas.openxmlformats.org/presentationml/2006/main">
   <p:cSld>
     <p:spTree>
       <p:nvGrpSpPr>
@@ -980,7 +774,7 @@
         <p:nvSpPr>
           <p:cNvPr id="2" name="Slide Image Placeholder 1"/>
           <p:cNvSpPr>
-            <a:spLocks noGrp="1"/>
+            <a:spLocks noGrp="1" noRot="1" noChangeAspect="1"/>
           </p:cNvSpPr>
           <p:nvPr>
             <p:ph type="sldImg" idx="2"/>
@@ -995,7 +789,7 @@
             <a:spLocks noGrp="1"/>
           </p:cNvSpPr>
           <p:nvPr>
-            <p:ph type="body" idx="3" sz="quarter"/>
+            <p:ph type="body" sz="quarter" idx="3"/>
           </p:nvPr>
         </p:nvSpPr>
         <p:spPr/>
@@ -1016,7 +810,7 @@
             <a:spLocks noGrp="1"/>
           </p:cNvSpPr>
           <p:nvPr>
-            <p:ph type="sldNum" idx="5" sz="quarter"/>
+            <p:ph type="sldNum" sz="quarter" idx="5"/>
           </p:nvPr>
         </p:nvSpPr>
         <p:spPr/>
@@ -1030,7 +824,7 @@
 </file>
 
 <file path=ppt/notesSlides/notesSlide5.xml><?xml version="1.0" encoding="utf-8"?>
-<p:notes xmlns:a="http://schemas.openxmlformats.org/drawingml/2006/main" xmlns:p="http://schemas.openxmlformats.org/presentationml/2006/main" xmlns:r="http://schemas.openxmlformats.org/officeDocument/2006/relationships">
+<p:notes xmlns:a="http://schemas.openxmlformats.org/drawingml/2006/main" xmlns:r="http://schemas.openxmlformats.org/officeDocument/2006/relationships" xmlns:p="http://schemas.openxmlformats.org/presentationml/2006/main">
   <p:cSld>
     <p:spTree>
       <p:nvGrpSpPr>
@@ -1050,7 +844,7 @@
         <p:nvSpPr>
           <p:cNvPr id="2" name="Slide Image Placeholder 1"/>
           <p:cNvSpPr>
-            <a:spLocks noGrp="1"/>
+            <a:spLocks noGrp="1" noRot="1" noChangeAspect="1"/>
           </p:cNvSpPr>
           <p:nvPr>
             <p:ph type="sldImg" idx="2"/>
@@ -1065,7 +859,7 @@
             <a:spLocks noGrp="1"/>
           </p:cNvSpPr>
           <p:nvPr>
-            <p:ph type="body" idx="3" sz="quarter"/>
+            <p:ph type="body" sz="quarter" idx="3"/>
           </p:nvPr>
         </p:nvSpPr>
         <p:spPr/>
@@ -1086,7 +880,7 @@
             <a:spLocks noGrp="1"/>
           </p:cNvSpPr>
           <p:nvPr>
-            <p:ph type="sldNum" idx="5" sz="quarter"/>
+            <p:ph type="sldNum" sz="quarter" idx="5"/>
           </p:nvPr>
         </p:nvSpPr>
         <p:spPr/>
@@ -1100,7 +894,7 @@
 </file>
 
 <file path=ppt/notesSlides/notesSlide6.xml><?xml version="1.0" encoding="utf-8"?>
-<p:notes xmlns:a="http://schemas.openxmlformats.org/drawingml/2006/main" xmlns:p="http://schemas.openxmlformats.org/presentationml/2006/main" xmlns:r="http://schemas.openxmlformats.org/officeDocument/2006/relationships">
+<p:notes xmlns:a="http://schemas.openxmlformats.org/drawingml/2006/main" xmlns:r="http://schemas.openxmlformats.org/officeDocument/2006/relationships" xmlns:p="http://schemas.openxmlformats.org/presentationml/2006/main">
   <p:cSld>
     <p:spTree>
       <p:nvGrpSpPr>
@@ -1120,7 +914,7 @@
         <p:nvSpPr>
           <p:cNvPr id="2" name="Slide Image Placeholder 1"/>
           <p:cNvSpPr>
-            <a:spLocks noGrp="1"/>
+            <a:spLocks noGrp="1" noRot="1" noChangeAspect="1"/>
           </p:cNvSpPr>
           <p:nvPr>
             <p:ph type="sldImg" idx="2"/>
@@ -1135,7 +929,7 @@
             <a:spLocks noGrp="1"/>
           </p:cNvSpPr>
           <p:nvPr>
-            <p:ph type="body" idx="3" sz="quarter"/>
+            <p:ph type="body" sz="quarter" idx="3"/>
           </p:nvPr>
         </p:nvSpPr>
         <p:spPr/>
@@ -1156,7 +950,7 @@
             <a:spLocks noGrp="1"/>
           </p:cNvSpPr>
           <p:nvPr>
-            <p:ph type="sldNum" idx="5" sz="quarter"/>
+            <p:ph type="sldNum" sz="quarter" idx="5"/>
           </p:nvPr>
         </p:nvSpPr>
         <p:spPr/>
@@ -1170,7 +964,7 @@
 </file>
 
 <file path=ppt/notesSlides/notesSlide7.xml><?xml version="1.0" encoding="utf-8"?>
-<p:notes xmlns:a="http://schemas.openxmlformats.org/drawingml/2006/main" xmlns:p="http://schemas.openxmlformats.org/presentationml/2006/main" xmlns:r="http://schemas.openxmlformats.org/officeDocument/2006/relationships">
+<p:notes xmlns:a="http://schemas.openxmlformats.org/drawingml/2006/main" xmlns:r="http://schemas.openxmlformats.org/officeDocument/2006/relationships" xmlns:p="http://schemas.openxmlformats.org/presentationml/2006/main">
   <p:cSld>
     <p:spTree>
       <p:nvGrpSpPr>
@@ -1190,7 +984,7 @@
         <p:nvSpPr>
           <p:cNvPr id="2" name="Slide Image Placeholder 1"/>
           <p:cNvSpPr>
-            <a:spLocks noGrp="1"/>
+            <a:spLocks noGrp="1" noRot="1" noChangeAspect="1"/>
           </p:cNvSpPr>
           <p:nvPr>
             <p:ph type="sldImg" idx="2"/>
@@ -1205,7 +999,7 @@
             <a:spLocks noGrp="1"/>
           </p:cNvSpPr>
           <p:nvPr>
-            <p:ph type="body" idx="3" sz="quarter"/>
+            <p:ph type="body" sz="quarter" idx="3"/>
           </p:nvPr>
         </p:nvSpPr>
         <p:spPr/>
@@ -1226,7 +1020,7 @@
             <a:spLocks noGrp="1"/>
           </p:cNvSpPr>
           <p:nvPr>
-            <p:ph type="sldNum" idx="5" sz="quarter"/>
+            <p:ph type="sldNum" sz="quarter" idx="5"/>
           </p:nvPr>
         </p:nvSpPr>
         <p:spPr/>
@@ -1240,7 +1034,7 @@
 </file>
 
 <file path=ppt/notesSlides/notesSlide8.xml><?xml version="1.0" encoding="utf-8"?>
-<p:notes xmlns:a="http://schemas.openxmlformats.org/drawingml/2006/main" xmlns:p="http://schemas.openxmlformats.org/presentationml/2006/main" xmlns:r="http://schemas.openxmlformats.org/officeDocument/2006/relationships">
+<p:notes xmlns:a="http://schemas.openxmlformats.org/drawingml/2006/main" xmlns:r="http://schemas.openxmlformats.org/officeDocument/2006/relationships" xmlns:p="http://schemas.openxmlformats.org/presentationml/2006/main">
   <p:cSld>
     <p:spTree>
       <p:nvGrpSpPr>
@@ -1260,7 +1054,7 @@
         <p:nvSpPr>
           <p:cNvPr id="2" name="Slide Image Placeholder 1"/>
           <p:cNvSpPr>
-            <a:spLocks noGrp="1"/>
+            <a:spLocks noGrp="1" noRot="1" noChangeAspect="1"/>
           </p:cNvSpPr>
           <p:nvPr>
             <p:ph type="sldImg" idx="2"/>
@@ -1275,7 +1069,7 @@
             <a:spLocks noGrp="1"/>
           </p:cNvSpPr>
           <p:nvPr>
-            <p:ph type="body" idx="3" sz="quarter"/>
+            <p:ph type="body" sz="quarter" idx="3"/>
           </p:nvPr>
         </p:nvSpPr>
         <p:spPr/>
@@ -1296,7 +1090,7 @@
             <a:spLocks noGrp="1"/>
           </p:cNvSpPr>
           <p:nvPr>
-            <p:ph type="sldNum" idx="5" sz="quarter"/>
+            <p:ph type="sldNum" sz="quarter" idx="5"/>
           </p:nvPr>
         </p:nvSpPr>
         <p:spPr/>
@@ -1310,7 +1104,7 @@
 </file>
 
 <file path=ppt/notesSlides/notesSlide9.xml><?xml version="1.0" encoding="utf-8"?>
-<p:notes xmlns:a="http://schemas.openxmlformats.org/drawingml/2006/main" xmlns:p="http://schemas.openxmlformats.org/presentationml/2006/main" xmlns:r="http://schemas.openxmlformats.org/officeDocument/2006/relationships">
+<p:notes xmlns:a="http://schemas.openxmlformats.org/drawingml/2006/main" xmlns:r="http://schemas.openxmlformats.org/officeDocument/2006/relationships" xmlns:p="http://schemas.openxmlformats.org/presentationml/2006/main">
   <p:cSld>
     <p:spTree>
       <p:nvGrpSpPr>
@@ -1330,7 +1124,7 @@
         <p:nvSpPr>
           <p:cNvPr id="2" name="Slide Image Placeholder 1"/>
           <p:cNvSpPr>
-            <a:spLocks noGrp="1"/>
+            <a:spLocks noGrp="1" noRot="1" noChangeAspect="1"/>
           </p:cNvSpPr>
           <p:nvPr>
             <p:ph type="sldImg" idx="2"/>
@@ -1345,7 +1139,7 @@
             <a:spLocks noGrp="1"/>
           </p:cNvSpPr>
           <p:nvPr>
-            <p:ph type="body" idx="3" sz="quarter"/>
+            <p:ph type="body" sz="quarter" idx="3"/>
           </p:nvPr>
         </p:nvSpPr>
         <p:spPr/>
@@ -1366,7 +1160,7 @@
             <a:spLocks noGrp="1"/>
           </p:cNvSpPr>
           <p:nvPr>
-            <p:ph type="sldNum" idx="5" sz="quarter"/>
+            <p:ph type="sldNum" sz="quarter" idx="5"/>
           </p:nvPr>
         </p:nvSpPr>
         <p:spPr/>
@@ -1417,10 +1211,9 @@
           <a:lstStyle/>
           <a:p>
             <a:r>
-              <a:rPr lang="en-US" smtClean="0"/>
+              <a:rPr lang="en-US"/>
               <a:t>Click to edit Master title style</a:t>
             </a:r>
-            <a:endParaRPr lang="en-US"/>
           </a:p>
         </p:txBody>
       </p:sp>
@@ -1536,10 +1329,9 @@
           </a:lstStyle>
           <a:p>
             <a:r>
-              <a:rPr lang="en-US" smtClean="0"/>
+              <a:rPr lang="en-US"/>
               <a:t>Click to edit Master subtitle style</a:t>
             </a:r>
-            <a:endParaRPr lang="en-US"/>
           </a:p>
         </p:txBody>
       </p:sp>
@@ -1560,7 +1352,7 @@
           <a:p>
             <a:fld id="{5BCAD085-E8A6-8845-BD4E-CB4CCA059FC4}" type="datetimeFigureOut">
               <a:rPr lang="en-US" smtClean="0"/>
-              <a:t>1/27/13</a:t>
+              <a:t>3/2/26</a:t>
             </a:fld>
             <a:endParaRPr lang="en-US"/>
           </a:p>
@@ -1654,10 +1446,9 @@
           <a:lstStyle/>
           <a:p>
             <a:r>
-              <a:rPr lang="en-US" smtClean="0"/>
+              <a:rPr lang="en-US"/>
               <a:t>Click to edit Master title style</a:t>
             </a:r>
-            <a:endParaRPr lang="en-US"/>
           </a:p>
         </p:txBody>
       </p:sp>
@@ -1678,38 +1469,37 @@
           <a:p>
             <a:pPr lvl="0"/>
             <a:r>
-              <a:rPr lang="en-US" smtClean="0"/>
+              <a:rPr lang="en-US"/>
               <a:t>Click to edit Master text styles</a:t>
             </a:r>
           </a:p>
           <a:p>
             <a:pPr lvl="1"/>
             <a:r>
-              <a:rPr lang="en-US" smtClean="0"/>
+              <a:rPr lang="en-US"/>
               <a:t>Second level</a:t>
             </a:r>
           </a:p>
           <a:p>
             <a:pPr lvl="2"/>
             <a:r>
-              <a:rPr lang="en-US" smtClean="0"/>
+              <a:rPr lang="en-US"/>
               <a:t>Third level</a:t>
             </a:r>
           </a:p>
           <a:p>
             <a:pPr lvl="3"/>
             <a:r>
-              <a:rPr lang="en-US" smtClean="0"/>
+              <a:rPr lang="en-US"/>
               <a:t>Fourth level</a:t>
             </a:r>
           </a:p>
           <a:p>
             <a:pPr lvl="4"/>
             <a:r>
-              <a:rPr lang="en-US" smtClean="0"/>
+              <a:rPr lang="en-US"/>
               <a:t>Fifth level</a:t>
             </a:r>
-            <a:endParaRPr lang="en-US"/>
           </a:p>
         </p:txBody>
       </p:sp>
@@ -1730,7 +1520,7 @@
           <a:p>
             <a:fld id="{5BCAD085-E8A6-8845-BD4E-CB4CCA059FC4}" type="datetimeFigureOut">
               <a:rPr lang="en-US" smtClean="0"/>
-              <a:t>1/27/13</a:t>
+              <a:t>3/2/26</a:t>
             </a:fld>
             <a:endParaRPr lang="en-US"/>
           </a:p>
@@ -1829,10 +1619,9 @@
           <a:lstStyle/>
           <a:p>
             <a:r>
-              <a:rPr lang="en-US" smtClean="0"/>
+              <a:rPr lang="en-US"/>
               <a:t>Click to edit Master title style</a:t>
             </a:r>
-            <a:endParaRPr lang="en-US"/>
           </a:p>
         </p:txBody>
       </p:sp>
@@ -1858,38 +1647,37 @@
           <a:p>
             <a:pPr lvl="0"/>
             <a:r>
-              <a:rPr lang="en-US" smtClean="0"/>
+              <a:rPr lang="en-US"/>
               <a:t>Click to edit Master text styles</a:t>
             </a:r>
           </a:p>
           <a:p>
             <a:pPr lvl="1"/>
             <a:r>
-              <a:rPr lang="en-US" smtClean="0"/>
+              <a:rPr lang="en-US"/>
               <a:t>Second level</a:t>
             </a:r>
           </a:p>
           <a:p>
             <a:pPr lvl="2"/>
             <a:r>
-              <a:rPr lang="en-US" smtClean="0"/>
+              <a:rPr lang="en-US"/>
               <a:t>Third level</a:t>
             </a:r>
           </a:p>
           <a:p>
             <a:pPr lvl="3"/>
             <a:r>
-              <a:rPr lang="en-US" smtClean="0"/>
+              <a:rPr lang="en-US"/>
               <a:t>Fourth level</a:t>
             </a:r>
           </a:p>
           <a:p>
             <a:pPr lvl="4"/>
             <a:r>
-              <a:rPr lang="en-US" smtClean="0"/>
+              <a:rPr lang="en-US"/>
               <a:t>Fifth level</a:t>
             </a:r>
-            <a:endParaRPr lang="en-US"/>
           </a:p>
         </p:txBody>
       </p:sp>
@@ -1910,7 +1698,7 @@
           <a:p>
             <a:fld id="{5BCAD085-E8A6-8845-BD4E-CB4CCA059FC4}" type="datetimeFigureOut">
               <a:rPr lang="en-US" smtClean="0"/>
-              <a:t>1/27/13</a:t>
+              <a:t>3/2/26</a:t>
             </a:fld>
             <a:endParaRPr lang="en-US"/>
           </a:p>
@@ -2004,10 +1792,9 @@
           <a:lstStyle/>
           <a:p>
             <a:r>
-              <a:rPr lang="en-US" smtClean="0"/>
+              <a:rPr lang="en-US"/>
               <a:t>Click to edit Master title style</a:t>
             </a:r>
-            <a:endParaRPr lang="en-US"/>
           </a:p>
         </p:txBody>
       </p:sp>
@@ -2028,38 +1815,37 @@
           <a:p>
             <a:pPr lvl="0"/>
             <a:r>
-              <a:rPr lang="en-US" smtClean="0"/>
+              <a:rPr lang="en-US"/>
               <a:t>Click to edit Master text styles</a:t>
             </a:r>
           </a:p>
           <a:p>
             <a:pPr lvl="1"/>
             <a:r>
-              <a:rPr lang="en-US" smtClean="0"/>
+              <a:rPr lang="en-US"/>
               <a:t>Second level</a:t>
             </a:r>
           </a:p>
           <a:p>
             <a:pPr lvl="2"/>
             <a:r>
-              <a:rPr lang="en-US" smtClean="0"/>
+              <a:rPr lang="en-US"/>
               <a:t>Third level</a:t>
             </a:r>
           </a:p>
           <a:p>
             <a:pPr lvl="3"/>
             <a:r>
-              <a:rPr lang="en-US" smtClean="0"/>
+              <a:rPr lang="en-US"/>
               <a:t>Fourth level</a:t>
             </a:r>
           </a:p>
           <a:p>
             <a:pPr lvl="4"/>
             <a:r>
-              <a:rPr lang="en-US" smtClean="0"/>
+              <a:rPr lang="en-US"/>
               <a:t>Fifth level</a:t>
             </a:r>
-            <a:endParaRPr lang="en-US"/>
           </a:p>
         </p:txBody>
       </p:sp>
@@ -2080,7 +1866,7 @@
           <a:p>
             <a:fld id="{5BCAD085-E8A6-8845-BD4E-CB4CCA059FC4}" type="datetimeFigureOut">
               <a:rPr lang="en-US" smtClean="0"/>
-              <a:t>1/27/13</a:t>
+              <a:t>3/2/26</a:t>
             </a:fld>
             <a:endParaRPr lang="en-US"/>
           </a:p>
@@ -2183,10 +1969,9 @@
           </a:lstStyle>
           <a:p>
             <a:r>
-              <a:rPr lang="en-US" smtClean="0"/>
+              <a:rPr lang="en-US"/>
               <a:t>Click to edit Master title style</a:t>
             </a:r>
-            <a:endParaRPr lang="en-US"/>
           </a:p>
         </p:txBody>
       </p:sp>
@@ -2303,7 +2088,7 @@
           <a:p>
             <a:pPr lvl="0"/>
             <a:r>
-              <a:rPr lang="en-US" smtClean="0"/>
+              <a:rPr lang="en-US"/>
               <a:t>Click to edit Master text styles</a:t>
             </a:r>
           </a:p>
@@ -2326,7 +2111,7 @@
           <a:p>
             <a:fld id="{5BCAD085-E8A6-8845-BD4E-CB4CCA059FC4}" type="datetimeFigureOut">
               <a:rPr lang="en-US" smtClean="0"/>
-              <a:t>1/27/13</a:t>
+              <a:t>3/2/26</a:t>
             </a:fld>
             <a:endParaRPr lang="en-US"/>
           </a:p>
@@ -2420,10 +2205,9 @@
           <a:lstStyle/>
           <a:p>
             <a:r>
-              <a:rPr lang="en-US" smtClean="0"/>
+              <a:rPr lang="en-US"/>
               <a:t>Click to edit Master title style</a:t>
             </a:r>
-            <a:endParaRPr lang="en-US"/>
           </a:p>
         </p:txBody>
       </p:sp>
@@ -2477,38 +2261,37 @@
           <a:p>
             <a:pPr lvl="0"/>
             <a:r>
-              <a:rPr lang="en-US" smtClean="0"/>
+              <a:rPr lang="en-US"/>
               <a:t>Click to edit Master text styles</a:t>
             </a:r>
           </a:p>
           <a:p>
             <a:pPr lvl="1"/>
             <a:r>
-              <a:rPr lang="en-US" smtClean="0"/>
+              <a:rPr lang="en-US"/>
               <a:t>Second level</a:t>
             </a:r>
           </a:p>
           <a:p>
             <a:pPr lvl="2"/>
             <a:r>
-              <a:rPr lang="en-US" smtClean="0"/>
+              <a:rPr lang="en-US"/>
               <a:t>Third level</a:t>
             </a:r>
           </a:p>
           <a:p>
             <a:pPr lvl="3"/>
             <a:r>
-              <a:rPr lang="en-US" smtClean="0"/>
+              <a:rPr lang="en-US"/>
               <a:t>Fourth level</a:t>
             </a:r>
           </a:p>
           <a:p>
             <a:pPr lvl="4"/>
             <a:r>
-              <a:rPr lang="en-US" smtClean="0"/>
+              <a:rPr lang="en-US"/>
               <a:t>Fifth level</a:t>
             </a:r>
-            <a:endParaRPr lang="en-US"/>
           </a:p>
         </p:txBody>
       </p:sp>
@@ -2562,38 +2345,37 @@
           <a:p>
             <a:pPr lvl="0"/>
             <a:r>
-              <a:rPr lang="en-US" smtClean="0"/>
+              <a:rPr lang="en-US"/>
               <a:t>Click to edit Master text styles</a:t>
             </a:r>
           </a:p>
           <a:p>
             <a:pPr lvl="1"/>
             <a:r>
-              <a:rPr lang="en-US" smtClean="0"/>
+              <a:rPr lang="en-US"/>
               <a:t>Second level</a:t>
             </a:r>
           </a:p>
           <a:p>
             <a:pPr lvl="2"/>
             <a:r>
-              <a:rPr lang="en-US" smtClean="0"/>
+              <a:rPr lang="en-US"/>
               <a:t>Third level</a:t>
             </a:r>
           </a:p>
           <a:p>
             <a:pPr lvl="3"/>
             <a:r>
-              <a:rPr lang="en-US" smtClean="0"/>
+              <a:rPr lang="en-US"/>
               <a:t>Fourth level</a:t>
             </a:r>
           </a:p>
           <a:p>
             <a:pPr lvl="4"/>
             <a:r>
-              <a:rPr lang="en-US" smtClean="0"/>
+              <a:rPr lang="en-US"/>
               <a:t>Fifth level</a:t>
             </a:r>
-            <a:endParaRPr lang="en-US"/>
           </a:p>
         </p:txBody>
       </p:sp>
@@ -2614,7 +2396,7 @@
           <a:p>
             <a:fld id="{5BCAD085-E8A6-8845-BD4E-CB4CCA059FC4}" type="datetimeFigureOut">
               <a:rPr lang="en-US" smtClean="0"/>
-              <a:t>1/27/13</a:t>
+              <a:t>3/2/26</a:t>
             </a:fld>
             <a:endParaRPr lang="en-US"/>
           </a:p>
@@ -2712,10 +2494,9 @@
           </a:lstStyle>
           <a:p>
             <a:r>
-              <a:rPr lang="en-US" smtClean="0"/>
+              <a:rPr lang="en-US"/>
               <a:t>Click to edit Master title style</a:t>
             </a:r>
-            <a:endParaRPr lang="en-US"/>
           </a:p>
         </p:txBody>
       </p:sp>
@@ -2778,7 +2559,7 @@
           <a:p>
             <a:pPr lvl="0"/>
             <a:r>
-              <a:rPr lang="en-US" smtClean="0"/>
+              <a:rPr lang="en-US"/>
               <a:t>Click to edit Master text styles</a:t>
             </a:r>
           </a:p>
@@ -2834,38 +2615,37 @@
           <a:p>
             <a:pPr lvl="0"/>
             <a:r>
-              <a:rPr lang="en-US" smtClean="0"/>
+              <a:rPr lang="en-US"/>
               <a:t>Click to edit Master text styles</a:t>
             </a:r>
           </a:p>
           <a:p>
             <a:pPr lvl="1"/>
             <a:r>
-              <a:rPr lang="en-US" smtClean="0"/>
+              <a:rPr lang="en-US"/>
               <a:t>Second level</a:t>
             </a:r>
           </a:p>
           <a:p>
             <a:pPr lvl="2"/>
             <a:r>
-              <a:rPr lang="en-US" smtClean="0"/>
+              <a:rPr lang="en-US"/>
               <a:t>Third level</a:t>
             </a:r>
           </a:p>
           <a:p>
             <a:pPr lvl="3"/>
             <a:r>
-              <a:rPr lang="en-US" smtClean="0"/>
+              <a:rPr lang="en-US"/>
               <a:t>Fourth level</a:t>
             </a:r>
           </a:p>
           <a:p>
             <a:pPr lvl="4"/>
             <a:r>
-              <a:rPr lang="en-US" smtClean="0"/>
+              <a:rPr lang="en-US"/>
               <a:t>Fifth level</a:t>
             </a:r>
-            <a:endParaRPr lang="en-US"/>
           </a:p>
         </p:txBody>
       </p:sp>
@@ -2928,7 +2708,7 @@
           <a:p>
             <a:pPr lvl="0"/>
             <a:r>
-              <a:rPr lang="en-US" smtClean="0"/>
+              <a:rPr lang="en-US"/>
               <a:t>Click to edit Master text styles</a:t>
             </a:r>
           </a:p>
@@ -2984,38 +2764,37 @@
           <a:p>
             <a:pPr lvl="0"/>
             <a:r>
-              <a:rPr lang="en-US" smtClean="0"/>
+              <a:rPr lang="en-US"/>
               <a:t>Click to edit Master text styles</a:t>
             </a:r>
           </a:p>
           <a:p>
             <a:pPr lvl="1"/>
             <a:r>
-              <a:rPr lang="en-US" smtClean="0"/>
+              <a:rPr lang="en-US"/>
               <a:t>Second level</a:t>
             </a:r>
           </a:p>
           <a:p>
             <a:pPr lvl="2"/>
             <a:r>
-              <a:rPr lang="en-US" smtClean="0"/>
+              <a:rPr lang="en-US"/>
               <a:t>Third level</a:t>
             </a:r>
           </a:p>
           <a:p>
             <a:pPr lvl="3"/>
             <a:r>
-              <a:rPr lang="en-US" smtClean="0"/>
+              <a:rPr lang="en-US"/>
               <a:t>Fourth level</a:t>
             </a:r>
           </a:p>
           <a:p>
             <a:pPr lvl="4"/>
             <a:r>
-              <a:rPr lang="en-US" smtClean="0"/>
+              <a:rPr lang="en-US"/>
               <a:t>Fifth level</a:t>
             </a:r>
-            <a:endParaRPr lang="en-US"/>
           </a:p>
         </p:txBody>
       </p:sp>
@@ -3036,7 +2815,7 @@
           <a:p>
             <a:fld id="{5BCAD085-E8A6-8845-BD4E-CB4CCA059FC4}" type="datetimeFigureOut">
               <a:rPr lang="en-US" smtClean="0"/>
-              <a:t>1/27/13</a:t>
+              <a:t>3/2/26</a:t>
             </a:fld>
             <a:endParaRPr lang="en-US"/>
           </a:p>
@@ -3130,10 +2909,9 @@
           <a:lstStyle/>
           <a:p>
             <a:r>
-              <a:rPr lang="en-US" smtClean="0"/>
+              <a:rPr lang="en-US"/>
               <a:t>Click to edit Master title style</a:t>
             </a:r>
-            <a:endParaRPr lang="en-US"/>
           </a:p>
         </p:txBody>
       </p:sp>
@@ -3154,7 +2932,7 @@
           <a:p>
             <a:fld id="{5BCAD085-E8A6-8845-BD4E-CB4CCA059FC4}" type="datetimeFigureOut">
               <a:rPr lang="en-US" smtClean="0"/>
-              <a:t>1/27/13</a:t>
+              <a:t>3/2/26</a:t>
             </a:fld>
             <a:endParaRPr lang="en-US"/>
           </a:p>
@@ -3249,7 +3027,7 @@
           <a:p>
             <a:fld id="{5BCAD085-E8A6-8845-BD4E-CB4CCA059FC4}" type="datetimeFigureOut">
               <a:rPr lang="en-US" smtClean="0"/>
-              <a:t>1/27/13</a:t>
+              <a:t>3/2/26</a:t>
             </a:fld>
             <a:endParaRPr lang="en-US"/>
           </a:p>
@@ -3352,10 +3130,9 @@
           </a:lstStyle>
           <a:p>
             <a:r>
-              <a:rPr lang="en-US" smtClean="0"/>
+              <a:rPr lang="en-US"/>
               <a:t>Click to edit Master title style</a:t>
             </a:r>
-            <a:endParaRPr lang="en-US"/>
           </a:p>
         </p:txBody>
       </p:sp>
@@ -3409,38 +3186,37 @@
           <a:p>
             <a:pPr lvl="0"/>
             <a:r>
-              <a:rPr lang="en-US" smtClean="0"/>
+              <a:rPr lang="en-US"/>
               <a:t>Click to edit Master text styles</a:t>
             </a:r>
           </a:p>
           <a:p>
             <a:pPr lvl="1"/>
             <a:r>
-              <a:rPr lang="en-US" smtClean="0"/>
+              <a:rPr lang="en-US"/>
               <a:t>Second level</a:t>
             </a:r>
           </a:p>
           <a:p>
             <a:pPr lvl="2"/>
             <a:r>
-              <a:rPr lang="en-US" smtClean="0"/>
+              <a:rPr lang="en-US"/>
               <a:t>Third level</a:t>
             </a:r>
           </a:p>
           <a:p>
             <a:pPr lvl="3"/>
             <a:r>
-              <a:rPr lang="en-US" smtClean="0"/>
+              <a:rPr lang="en-US"/>
               <a:t>Fourth level</a:t>
             </a:r>
           </a:p>
           <a:p>
             <a:pPr lvl="4"/>
             <a:r>
-              <a:rPr lang="en-US" smtClean="0"/>
+              <a:rPr lang="en-US"/>
               <a:t>Fifth level</a:t>
             </a:r>
-            <a:endParaRPr lang="en-US"/>
           </a:p>
         </p:txBody>
       </p:sp>
@@ -3503,7 +3279,7 @@
           <a:p>
             <a:pPr lvl="0"/>
             <a:r>
-              <a:rPr lang="en-US" smtClean="0"/>
+              <a:rPr lang="en-US"/>
               <a:t>Click to edit Master text styles</a:t>
             </a:r>
           </a:p>
@@ -3526,7 +3302,7 @@
           <a:p>
             <a:fld id="{5BCAD085-E8A6-8845-BD4E-CB4CCA059FC4}" type="datetimeFigureOut">
               <a:rPr lang="en-US" smtClean="0"/>
-              <a:t>1/27/13</a:t>
+              <a:t>3/2/26</a:t>
             </a:fld>
             <a:endParaRPr lang="en-US"/>
           </a:p>
@@ -3629,10 +3405,9 @@
           </a:lstStyle>
           <a:p>
             <a:r>
-              <a:rPr lang="en-US" smtClean="0"/>
+              <a:rPr lang="en-US"/>
               <a:t>Click to edit Master title style</a:t>
             </a:r>
-            <a:endParaRPr lang="en-US"/>
           </a:p>
         </p:txBody>
       </p:sp>
@@ -3756,7 +3531,7 @@
           <a:p>
             <a:pPr lvl="0"/>
             <a:r>
-              <a:rPr lang="en-US" smtClean="0"/>
+              <a:rPr lang="en-US"/>
               <a:t>Click to edit Master text styles</a:t>
             </a:r>
           </a:p>
@@ -3779,7 +3554,7 @@
           <a:p>
             <a:fld id="{5BCAD085-E8A6-8845-BD4E-CB4CCA059FC4}" type="datetimeFigureOut">
               <a:rPr lang="en-US" smtClean="0"/>
-              <a:t>1/27/13</a:t>
+              <a:t>3/2/26</a:t>
             </a:fld>
             <a:endParaRPr lang="en-US"/>
           </a:p>
@@ -3888,10 +3663,9 @@
           <a:lstStyle/>
           <a:p>
             <a:r>
-              <a:rPr lang="en-US" smtClean="0"/>
+              <a:rPr lang="en-US"/>
               <a:t>Click to edit Master title style</a:t>
             </a:r>
-            <a:endParaRPr lang="en-US"/>
           </a:p>
         </p:txBody>
       </p:sp>
@@ -3922,38 +3696,37 @@
           <a:p>
             <a:pPr lvl="0"/>
             <a:r>
-              <a:rPr lang="en-US" smtClean="0"/>
+              <a:rPr lang="en-US"/>
               <a:t>Click to edit Master text styles</a:t>
             </a:r>
           </a:p>
           <a:p>
             <a:pPr lvl="1"/>
             <a:r>
-              <a:rPr lang="en-US" smtClean="0"/>
+              <a:rPr lang="en-US"/>
               <a:t>Second level</a:t>
             </a:r>
           </a:p>
           <a:p>
             <a:pPr lvl="2"/>
             <a:r>
-              <a:rPr lang="en-US" smtClean="0"/>
+              <a:rPr lang="en-US"/>
               <a:t>Third level</a:t>
             </a:r>
           </a:p>
           <a:p>
             <a:pPr lvl="3"/>
             <a:r>
-              <a:rPr lang="en-US" smtClean="0"/>
+              <a:rPr lang="en-US"/>
               <a:t>Fourth level</a:t>
             </a:r>
           </a:p>
           <a:p>
             <a:pPr lvl="4"/>
             <a:r>
-              <a:rPr lang="en-US" smtClean="0"/>
+              <a:rPr lang="en-US"/>
               <a:t>Fifth level</a:t>
             </a:r>
-            <a:endParaRPr lang="en-US"/>
           </a:p>
         </p:txBody>
       </p:sp>
@@ -3992,7 +3765,7 @@
           <a:p>
             <a:fld id="{5BCAD085-E8A6-8845-BD4E-CB4CCA059FC4}" type="datetimeFigureOut">
               <a:rPr lang="en-US" smtClean="0"/>
-              <a:t>1/27/13</a:t>
+              <a:t>3/2/26</a:t>
             </a:fld>
             <a:endParaRPr lang="en-US"/>
           </a:p>
@@ -4351,7 +4124,7 @@
 </file>
 
 <file path=ppt/slides/slide1.xml><?xml version="1.0" encoding="utf-8"?>
-<p:sld xmlns:a="http://schemas.openxmlformats.org/drawingml/2006/main" xmlns:p="http://schemas.openxmlformats.org/presentationml/2006/main" xmlns:r="http://schemas.openxmlformats.org/officeDocument/2006/relationships">
+<p:sld xmlns:a="http://schemas.openxmlformats.org/drawingml/2006/main" xmlns:r="http://schemas.openxmlformats.org/officeDocument/2006/relationships" xmlns:p="http://schemas.openxmlformats.org/presentationml/2006/main">
   <p:cSld>
     <p:bg>
       <p:bgPr>
@@ -4367,7 +4140,14 @@
         <p:cNvGrpSpPr/>
         <p:nvPr/>
       </p:nvGrpSpPr>
-      <p:grpSpPr/>
+      <p:grpSpPr>
+        <a:xfrm>
+          <a:off x="0" y="0"/>
+          <a:ext cx="0" cy="0"/>
+          <a:chOff x="0" y="0"/>
+          <a:chExt cx="0" cy="0"/>
+        </a:xfrm>
+      </p:grpSpPr>
       <p:sp>
         <p:nvSpPr>
           <p:cNvPr id="2" name="TextBox 1"/>
@@ -4521,6 +4301,7 @@
           <a:lstStyle/>
           <a:p>
             <a:pPr algn="ctr"/>
+            <a:endParaRPr/>
           </a:p>
         </p:txBody>
       </p:sp>
@@ -4646,7 +4427,7 @@
 </file>
 
 <file path=ppt/slides/slide10.xml><?xml version="1.0" encoding="utf-8"?>
-<p:sld xmlns:a="http://schemas.openxmlformats.org/drawingml/2006/main" xmlns:p="http://schemas.openxmlformats.org/presentationml/2006/main" xmlns:r="http://schemas.openxmlformats.org/officeDocument/2006/relationships">
+<p:sld xmlns:a="http://schemas.openxmlformats.org/drawingml/2006/main" xmlns:r="http://schemas.openxmlformats.org/officeDocument/2006/relationships" xmlns:p="http://schemas.openxmlformats.org/presentationml/2006/main">
   <p:cSld>
     <p:bg>
       <p:bgPr>
@@ -4662,7 +4443,14 @@
         <p:cNvGrpSpPr/>
         <p:nvPr/>
       </p:nvGrpSpPr>
-      <p:grpSpPr/>
+      <p:grpSpPr>
+        <a:xfrm>
+          <a:off x="0" y="0"/>
+          <a:ext cx="0" cy="0"/>
+          <a:chOff x="0" y="0"/>
+          <a:chExt cx="0" cy="0"/>
+        </a:xfrm>
+      </p:grpSpPr>
       <p:sp>
         <p:nvSpPr>
           <p:cNvPr id="2" name="TextBox 1"/>
@@ -4816,6 +4604,7 @@
           <a:lstStyle/>
           <a:p>
             <a:pPr algn="ctr"/>
+            <a:endParaRPr/>
           </a:p>
         </p:txBody>
       </p:sp>
@@ -4860,6 +4649,7 @@
           <a:lstStyle/>
           <a:p>
             <a:pPr algn="ctr"/>
+            <a:endParaRPr/>
           </a:p>
         </p:txBody>
       </p:sp>
@@ -4903,6 +4693,7 @@
           <a:lstStyle/>
           <a:p>
             <a:pPr algn="ctr"/>
+            <a:endParaRPr/>
           </a:p>
         </p:txBody>
       </p:sp>
@@ -5068,6 +4859,7 @@
           <a:lstStyle/>
           <a:p>
             <a:pPr algn="ctr"/>
+            <a:endParaRPr/>
           </a:p>
         </p:txBody>
       </p:sp>
@@ -5111,6 +4903,7 @@
           <a:lstStyle/>
           <a:p>
             <a:pPr algn="ctr"/>
+            <a:endParaRPr/>
           </a:p>
         </p:txBody>
       </p:sp>
@@ -5276,6 +5069,7 @@
           <a:lstStyle/>
           <a:p>
             <a:pPr algn="ctr"/>
+            <a:endParaRPr/>
           </a:p>
         </p:txBody>
       </p:sp>
@@ -5319,6 +5113,7 @@
           <a:lstStyle/>
           <a:p>
             <a:pPr algn="ctr"/>
+            <a:endParaRPr/>
           </a:p>
         </p:txBody>
       </p:sp>
@@ -5484,6 +5279,7 @@
           <a:lstStyle/>
           <a:p>
             <a:pPr algn="ctr"/>
+            <a:endParaRPr/>
           </a:p>
         </p:txBody>
       </p:sp>
@@ -5527,6 +5323,7 @@
           <a:lstStyle/>
           <a:p>
             <a:pPr algn="ctr"/>
+            <a:endParaRPr/>
           </a:p>
         </p:txBody>
       </p:sp>
@@ -5692,6 +5489,7 @@
           <a:lstStyle/>
           <a:p>
             <a:pPr algn="ctr"/>
+            <a:endParaRPr/>
           </a:p>
         </p:txBody>
       </p:sp>
@@ -5735,6 +5533,7 @@
           <a:lstStyle/>
           <a:p>
             <a:pPr algn="ctr"/>
+            <a:endParaRPr/>
           </a:p>
         </p:txBody>
       </p:sp>
@@ -5820,7 +5619,7 @@
 </file>
 
 <file path=ppt/slides/slide11.xml><?xml version="1.0" encoding="utf-8"?>
-<p:sld xmlns:a="http://schemas.openxmlformats.org/drawingml/2006/main" xmlns:p="http://schemas.openxmlformats.org/presentationml/2006/main" xmlns:r="http://schemas.openxmlformats.org/officeDocument/2006/relationships">
+<p:sld xmlns:a="http://schemas.openxmlformats.org/drawingml/2006/main" xmlns:r="http://schemas.openxmlformats.org/officeDocument/2006/relationships" xmlns:p="http://schemas.openxmlformats.org/presentationml/2006/main">
   <p:cSld>
     <p:bg>
       <p:bgPr>
@@ -5836,7 +5635,14 @@
         <p:cNvGrpSpPr/>
         <p:nvPr/>
       </p:nvGrpSpPr>
-      <p:grpSpPr/>
+      <p:grpSpPr>
+        <a:xfrm>
+          <a:off x="0" y="0"/>
+          <a:ext cx="0" cy="0"/>
+          <a:chOff x="0" y="0"/>
+          <a:chExt cx="0" cy="0"/>
+        </a:xfrm>
+      </p:grpSpPr>
       <p:sp>
         <p:nvSpPr>
           <p:cNvPr id="2" name="TextBox 1"/>
@@ -5990,6 +5796,7 @@
           <a:lstStyle/>
           <a:p>
             <a:pPr algn="ctr"/>
+            <a:endParaRPr/>
           </a:p>
         </p:txBody>
       </p:sp>
@@ -6034,6 +5841,7 @@
           <a:lstStyle/>
           <a:p>
             <a:pPr algn="ctr"/>
+            <a:endParaRPr/>
           </a:p>
         </p:txBody>
       </p:sp>
@@ -6077,6 +5885,7 @@
           <a:lstStyle/>
           <a:p>
             <a:pPr algn="ctr"/>
+            <a:endParaRPr/>
           </a:p>
         </p:txBody>
       </p:sp>
@@ -6237,15 +6046,12 @@
                 <a:spcPts val="600"/>
               </a:spcAft>
             </a:pPr>
-            <a:r>
-              <a:rPr sz="1200">
-                <a:solidFill>
-                  <a:srgbClr val="CBD5E1"/>
-                </a:solidFill>
-                <a:latin typeface="Inter"/>
-              </a:rPr>
-              <a:t/>
-            </a:r>
+            <a:endParaRPr sz="1200">
+              <a:solidFill>
+                <a:srgbClr val="CBD5E1"/>
+              </a:solidFill>
+              <a:latin typeface="Inter"/>
+            </a:endParaRPr>
           </a:p>
           <a:p>
             <a:pPr>
@@ -6306,6 +6112,7 @@
           <a:lstStyle/>
           <a:p>
             <a:pPr algn="ctr"/>
+            <a:endParaRPr/>
           </a:p>
         </p:txBody>
       </p:sp>
@@ -6349,6 +6156,7 @@
           <a:lstStyle/>
           <a:p>
             <a:pPr algn="ctr"/>
+            <a:endParaRPr/>
           </a:p>
         </p:txBody>
       </p:sp>
@@ -6509,15 +6317,12 @@
                 <a:spcPts val="600"/>
               </a:spcAft>
             </a:pPr>
-            <a:r>
-              <a:rPr sz="1200">
-                <a:solidFill>
-                  <a:srgbClr val="CBD5E1"/>
-                </a:solidFill>
-                <a:latin typeface="Inter"/>
-              </a:rPr>
-              <a:t/>
-            </a:r>
+            <a:endParaRPr sz="1200">
+              <a:solidFill>
+                <a:srgbClr val="CBD5E1"/>
+              </a:solidFill>
+              <a:latin typeface="Inter"/>
+            </a:endParaRPr>
           </a:p>
           <a:p>
             <a:pPr>
@@ -6546,7 +6351,7 @@
 </file>
 
 <file path=ppt/slides/slide12.xml><?xml version="1.0" encoding="utf-8"?>
-<p:sld xmlns:a="http://schemas.openxmlformats.org/drawingml/2006/main" xmlns:p="http://schemas.openxmlformats.org/presentationml/2006/main" xmlns:r="http://schemas.openxmlformats.org/officeDocument/2006/relationships">
+<p:sld xmlns:a="http://schemas.openxmlformats.org/drawingml/2006/main" xmlns:r="http://schemas.openxmlformats.org/officeDocument/2006/relationships" xmlns:p="http://schemas.openxmlformats.org/presentationml/2006/main">
   <p:cSld>
     <p:bg>
       <p:bgPr>
@@ -6562,7 +6367,14 @@
         <p:cNvGrpSpPr/>
         <p:nvPr/>
       </p:nvGrpSpPr>
-      <p:grpSpPr/>
+      <p:grpSpPr>
+        <a:xfrm>
+          <a:off x="0" y="0"/>
+          <a:ext cx="0" cy="0"/>
+          <a:chOff x="0" y="0"/>
+          <a:chExt cx="0" cy="0"/>
+        </a:xfrm>
+      </p:grpSpPr>
       <p:sp>
         <p:nvSpPr>
           <p:cNvPr id="2" name="TextBox 1"/>
@@ -6716,6 +6528,7 @@
           <a:lstStyle/>
           <a:p>
             <a:pPr algn="ctr"/>
+            <a:endParaRPr/>
           </a:p>
         </p:txBody>
       </p:sp>
@@ -6728,7 +6541,7 @@
         <p:spPr>
           <a:xfrm>
             <a:off x="731520" y="1645920"/>
-            <a:ext cx="9144000" cy="731520"/>
+            <a:ext cx="9144000" cy="369332"/>
           </a:xfrm>
           <a:prstGeom prst="rect">
             <a:avLst/>
@@ -6742,49 +6555,38 @@
           <a:lstStyle/>
           <a:p>
             <a:r>
-              <a:rPr sz="1800">
+              <a:rPr sz="1800" dirty="0">
                 <a:solidFill>
                   <a:srgbClr val="CBD5E1"/>
                 </a:solidFill>
                 <a:latin typeface="Inter"/>
               </a:rPr>
-              <a:t>The roadmap for Q2 – Q4 2026</a:t>
-            </a:r>
-          </a:p>
-        </p:txBody>
-      </p:sp>
-      <p:sp>
-        <p:nvSpPr>
-          <p:cNvPr id="7" name="TextBox 6"/>
-          <p:cNvSpPr txBox="1"/>
-          <p:nvPr/>
-        </p:nvSpPr>
-        <p:spPr>
-          <a:xfrm>
-            <a:off x="731520" y="2377440"/>
-            <a:ext cx="2011680" cy="274320"/>
-          </a:xfrm>
-          <a:prstGeom prst="rect">
-            <a:avLst/>
-          </a:prstGeom>
-          <a:noFill/>
-        </p:spPr>
-        <p:txBody>
-          <a:bodyPr wrap="none">
-            <a:spAutoFit/>
-          </a:bodyPr>
-          <a:lstStyle/>
-          <a:p>
-            <a:pPr algn="ctr"/>
-            <a:r>
-              <a:rPr sz="1100" b="1">
-                <a:solidFill>
-                  <a:srgbClr val="3B82F6"/>
-                </a:solidFill>
-                <a:latin typeface="Inter"/>
-              </a:rPr>
-              <a:t>Q2 2026</a:t>
-            </a:r>
+              <a:t>The roadmap for</a:t>
+            </a:r>
+            <a:r>
+              <a:rPr lang="pt-BR" sz="1800" dirty="0">
+                <a:solidFill>
+                  <a:srgbClr val="CBD5E1"/>
+                </a:solidFill>
+                <a:latin typeface="Inter"/>
+              </a:rPr>
+              <a:t> whats </a:t>
+            </a:r>
+            <a:r>
+              <a:rPr lang="pt-BR" sz="1800" dirty="0" err="1">
+                <a:solidFill>
+                  <a:srgbClr val="CBD5E1"/>
+                </a:solidFill>
+                <a:latin typeface="Inter"/>
+              </a:rPr>
+              <a:t>next</a:t>
+            </a:r>
+            <a:endParaRPr sz="1800" dirty="0">
+              <a:solidFill>
+                <a:srgbClr val="CBD5E1"/>
+              </a:solidFill>
+              <a:latin typeface="Inter"/>
+            </a:endParaRPr>
           </a:p>
         </p:txBody>
       </p:sp>
@@ -6829,6 +6631,7 @@
           <a:lstStyle/>
           <a:p>
             <a:pPr algn="ctr"/>
+            <a:endParaRPr/>
           </a:p>
         </p:txBody>
       </p:sp>
@@ -6872,6 +6675,7 @@
           <a:lstStyle/>
           <a:p>
             <a:pPr algn="ctr"/>
+            <a:endParaRPr/>
           </a:p>
         </p:txBody>
       </p:sp>
@@ -6961,41 +6765,6 @@
                 <a:latin typeface="Inter"/>
               </a:rPr>
               <a:t>and follow-ups automatically</a:t>
-            </a:r>
-          </a:p>
-        </p:txBody>
-      </p:sp>
-      <p:sp>
-        <p:nvSpPr>
-          <p:cNvPr id="12" name="TextBox 11"/>
-          <p:cNvSpPr txBox="1"/>
-          <p:nvPr/>
-        </p:nvSpPr>
-        <p:spPr>
-          <a:xfrm>
-            <a:off x="3017520" y="2377440"/>
-            <a:ext cx="2011680" cy="274320"/>
-          </a:xfrm>
-          <a:prstGeom prst="rect">
-            <a:avLst/>
-          </a:prstGeom>
-          <a:noFill/>
-        </p:spPr>
-        <p:txBody>
-          <a:bodyPr wrap="none">
-            <a:spAutoFit/>
-          </a:bodyPr>
-          <a:lstStyle/>
-          <a:p>
-            <a:pPr algn="ctr"/>
-            <a:r>
-              <a:rPr sz="1100" b="1">
-                <a:solidFill>
-                  <a:srgbClr val="3B82F6"/>
-                </a:solidFill>
-                <a:latin typeface="Inter"/>
-              </a:rPr>
-              <a:t>Q2 2026</a:t>
             </a:r>
           </a:p>
         </p:txBody>
@@ -7041,6 +6810,7 @@
           <a:lstStyle/>
           <a:p>
             <a:pPr algn="ctr"/>
+            <a:endParaRPr/>
           </a:p>
         </p:txBody>
       </p:sp>
@@ -7084,6 +6854,7 @@
           <a:lstStyle/>
           <a:p>
             <a:pPr algn="ctr"/>
+            <a:endParaRPr/>
           </a:p>
         </p:txBody>
       </p:sp>
@@ -7173,41 +6944,6 @@
                 <a:latin typeface="Inter"/>
               </a:rPr>
               <a:t>analysis, ROI dashboards</a:t>
-            </a:r>
-          </a:p>
-        </p:txBody>
-      </p:sp>
-      <p:sp>
-        <p:nvSpPr>
-          <p:cNvPr id="17" name="TextBox 16"/>
-          <p:cNvSpPr txBox="1"/>
-          <p:nvPr/>
-        </p:nvSpPr>
-        <p:spPr>
-          <a:xfrm>
-            <a:off x="5303520" y="2377440"/>
-            <a:ext cx="2011680" cy="274320"/>
-          </a:xfrm>
-          <a:prstGeom prst="rect">
-            <a:avLst/>
-          </a:prstGeom>
-          <a:noFill/>
-        </p:spPr>
-        <p:txBody>
-          <a:bodyPr wrap="none">
-            <a:spAutoFit/>
-          </a:bodyPr>
-          <a:lstStyle/>
-          <a:p>
-            <a:pPr algn="ctr"/>
-            <a:r>
-              <a:rPr sz="1100" b="1">
-                <a:solidFill>
-                  <a:srgbClr val="F59E0B"/>
-                </a:solidFill>
-                <a:latin typeface="Inter"/>
-              </a:rPr>
-              <a:t>Q3 2026</a:t>
             </a:r>
           </a:p>
         </p:txBody>
@@ -7253,6 +6989,7 @@
           <a:lstStyle/>
           <a:p>
             <a:pPr algn="ctr"/>
+            <a:endParaRPr/>
           </a:p>
         </p:txBody>
       </p:sp>
@@ -7296,6 +7033,7 @@
           <a:lstStyle/>
           <a:p>
             <a:pPr algn="ctr"/>
+            <a:endParaRPr/>
           </a:p>
         </p:txBody>
       </p:sp>
@@ -7385,41 +7123,6 @@
                 <a:latin typeface="Inter"/>
               </a:rPr>
               <a:t>zip code performance data</a:t>
-            </a:r>
-          </a:p>
-        </p:txBody>
-      </p:sp>
-      <p:sp>
-        <p:nvSpPr>
-          <p:cNvPr id="22" name="TextBox 21"/>
-          <p:cNvSpPr txBox="1"/>
-          <p:nvPr/>
-        </p:nvSpPr>
-        <p:spPr>
-          <a:xfrm>
-            <a:off x="7589520" y="2377440"/>
-            <a:ext cx="2011680" cy="274320"/>
-          </a:xfrm>
-          <a:prstGeom prst="rect">
-            <a:avLst/>
-          </a:prstGeom>
-          <a:noFill/>
-        </p:spPr>
-        <p:txBody>
-          <a:bodyPr wrap="none">
-            <a:spAutoFit/>
-          </a:bodyPr>
-          <a:lstStyle/>
-          <a:p>
-            <a:pPr algn="ctr"/>
-            <a:r>
-              <a:rPr sz="1100" b="1">
-                <a:solidFill>
-                  <a:srgbClr val="F59E0B"/>
-                </a:solidFill>
-                <a:latin typeface="Inter"/>
-              </a:rPr>
-              <a:t>Q3 2026</a:t>
             </a:r>
           </a:p>
         </p:txBody>
@@ -7465,6 +7168,7 @@
           <a:lstStyle/>
           <a:p>
             <a:pPr algn="ctr"/>
+            <a:endParaRPr/>
           </a:p>
         </p:txBody>
       </p:sp>
@@ -7508,6 +7212,7 @@
           <a:lstStyle/>
           <a:p>
             <a:pPr algn="ctr"/>
+            <a:endParaRPr/>
           </a:p>
         </p:txBody>
       </p:sp>
@@ -7596,41 +7301,6 @@
                 <a:latin typeface="Inter"/>
               </a:rPr>
               <a:t>for on-the-ground teams</a:t>
-            </a:r>
-          </a:p>
-        </p:txBody>
-      </p:sp>
-      <p:sp>
-        <p:nvSpPr>
-          <p:cNvPr id="27" name="TextBox 26"/>
-          <p:cNvSpPr txBox="1"/>
-          <p:nvPr/>
-        </p:nvSpPr>
-        <p:spPr>
-          <a:xfrm>
-            <a:off x="9875520" y="2377440"/>
-            <a:ext cx="2011680" cy="274320"/>
-          </a:xfrm>
-          <a:prstGeom prst="rect">
-            <a:avLst/>
-          </a:prstGeom>
-          <a:noFill/>
-        </p:spPr>
-        <p:txBody>
-          <a:bodyPr wrap="none">
-            <a:spAutoFit/>
-          </a:bodyPr>
-          <a:lstStyle/>
-          <a:p>
-            <a:pPr algn="ctr"/>
-            <a:r>
-              <a:rPr sz="1100" b="1">
-                <a:solidFill>
-                  <a:srgbClr val="22C55E"/>
-                </a:solidFill>
-                <a:latin typeface="Inter"/>
-              </a:rPr>
-              <a:t>Q4 2026</a:t>
             </a:r>
           </a:p>
         </p:txBody>
@@ -7676,6 +7346,7 @@
           <a:lstStyle/>
           <a:p>
             <a:pPr algn="ctr"/>
+            <a:endParaRPr/>
           </a:p>
         </p:txBody>
       </p:sp>
@@ -7719,6 +7390,7 @@
           <a:lstStyle/>
           <a:p>
             <a:pPr algn="ctr"/>
+            <a:endParaRPr/>
           </a:p>
         </p:txBody>
       </p:sp>
@@ -7852,6 +7524,7 @@
           <a:lstStyle/>
           <a:p>
             <a:pPr algn="ctr"/>
+            <a:endParaRPr/>
           </a:p>
         </p:txBody>
       </p:sp>
@@ -7864,7 +7537,7 @@
 </file>
 
 <file path=ppt/slides/slide13.xml><?xml version="1.0" encoding="utf-8"?>
-<p:sld xmlns:a="http://schemas.openxmlformats.org/drawingml/2006/main" xmlns:p="http://schemas.openxmlformats.org/presentationml/2006/main" xmlns:r="http://schemas.openxmlformats.org/officeDocument/2006/relationships">
+<p:sld xmlns:a="http://schemas.openxmlformats.org/drawingml/2006/main" xmlns:r="http://schemas.openxmlformats.org/officeDocument/2006/relationships" xmlns:p="http://schemas.openxmlformats.org/presentationml/2006/main">
   <p:cSld>
     <p:bg>
       <p:bgPr>
@@ -7880,7 +7553,14 @@
         <p:cNvGrpSpPr/>
         <p:nvPr/>
       </p:nvGrpSpPr>
-      <p:grpSpPr/>
+      <p:grpSpPr>
+        <a:xfrm>
+          <a:off x="0" y="0"/>
+          <a:ext cx="0" cy="0"/>
+          <a:chOff x="0" y="0"/>
+          <a:chExt cx="0" cy="0"/>
+        </a:xfrm>
+      </p:grpSpPr>
       <p:sp>
         <p:nvSpPr>
           <p:cNvPr id="2" name="TextBox 1"/>
@@ -8034,6 +7714,7 @@
           <a:lstStyle/>
           <a:p>
             <a:pPr algn="ctr"/>
+            <a:endParaRPr/>
           </a:p>
         </p:txBody>
       </p:sp>
@@ -8194,7 +7875,7 @@
 </file>
 
 <file path=ppt/slides/slide2.xml><?xml version="1.0" encoding="utf-8"?>
-<p:sld xmlns:a="http://schemas.openxmlformats.org/drawingml/2006/main" xmlns:p="http://schemas.openxmlformats.org/presentationml/2006/main" xmlns:r="http://schemas.openxmlformats.org/officeDocument/2006/relationships">
+<p:sld xmlns:a="http://schemas.openxmlformats.org/drawingml/2006/main" xmlns:r="http://schemas.openxmlformats.org/officeDocument/2006/relationships" xmlns:p="http://schemas.openxmlformats.org/presentationml/2006/main">
   <p:cSld>
     <p:bg>
       <p:bgPr>
@@ -8210,7 +7891,14 @@
         <p:cNvGrpSpPr/>
         <p:nvPr/>
       </p:nvGrpSpPr>
-      <p:grpSpPr/>
+      <p:grpSpPr>
+        <a:xfrm>
+          <a:off x="0" y="0"/>
+          <a:ext cx="0" cy="0"/>
+          <a:chOff x="0" y="0"/>
+          <a:chExt cx="0" cy="0"/>
+        </a:xfrm>
+      </p:grpSpPr>
       <p:sp>
         <p:nvSpPr>
           <p:cNvPr id="2" name="TextBox 1"/>
@@ -8398,6 +8086,7 @@
           <a:lstStyle/>
           <a:p>
             <a:pPr algn="ctr"/>
+            <a:endParaRPr/>
           </a:p>
         </p:txBody>
       </p:sp>
@@ -8563,6 +8252,7 @@
           <a:lstStyle/>
           <a:p>
             <a:pPr algn="ctr"/>
+            <a:endParaRPr/>
           </a:p>
         </p:txBody>
       </p:sp>
@@ -8610,7 +8300,7 @@
 </file>
 
 <file path=ppt/slides/slide3.xml><?xml version="1.0" encoding="utf-8"?>
-<p:sld xmlns:a="http://schemas.openxmlformats.org/drawingml/2006/main" xmlns:p="http://schemas.openxmlformats.org/presentationml/2006/main" xmlns:r="http://schemas.openxmlformats.org/officeDocument/2006/relationships">
+<p:sld xmlns:a="http://schemas.openxmlformats.org/drawingml/2006/main" xmlns:r="http://schemas.openxmlformats.org/officeDocument/2006/relationships" xmlns:p="http://schemas.openxmlformats.org/presentationml/2006/main">
   <p:cSld>
     <p:bg>
       <p:bgPr>
@@ -8626,7 +8316,14 @@
         <p:cNvGrpSpPr/>
         <p:nvPr/>
       </p:nvGrpSpPr>
-      <p:grpSpPr/>
+      <p:grpSpPr>
+        <a:xfrm>
+          <a:off x="0" y="0"/>
+          <a:ext cx="0" cy="0"/>
+          <a:chOff x="0" y="0"/>
+          <a:chExt cx="0" cy="0"/>
+        </a:xfrm>
+      </p:grpSpPr>
       <p:sp>
         <p:nvSpPr>
           <p:cNvPr id="2" name="TextBox 1"/>
@@ -8780,6 +8477,7 @@
           <a:lstStyle/>
           <a:p>
             <a:pPr algn="ctr"/>
+            <a:endParaRPr/>
           </a:p>
         </p:txBody>
       </p:sp>
@@ -8858,6 +8556,7 @@
           <a:lstStyle/>
           <a:p>
             <a:pPr algn="ctr"/>
+            <a:endParaRPr/>
           </a:p>
         </p:txBody>
       </p:sp>
@@ -8901,6 +8600,7 @@
           <a:lstStyle/>
           <a:p>
             <a:pPr algn="ctr"/>
+            <a:endParaRPr/>
           </a:p>
         </p:txBody>
       </p:sp>
@@ -9132,6 +8832,7 @@
           <a:lstStyle/>
           <a:p>
             <a:pPr algn="ctr"/>
+            <a:endParaRPr/>
           </a:p>
         </p:txBody>
       </p:sp>
@@ -9175,6 +8876,7 @@
           <a:lstStyle/>
           <a:p>
             <a:pPr algn="ctr"/>
+            <a:endParaRPr/>
           </a:p>
         </p:txBody>
       </p:sp>
@@ -9340,7 +9042,7 @@
 </file>
 
 <file path=ppt/slides/slide4.xml><?xml version="1.0" encoding="utf-8"?>
-<p:sld xmlns:a="http://schemas.openxmlformats.org/drawingml/2006/main" xmlns:p="http://schemas.openxmlformats.org/presentationml/2006/main" xmlns:r="http://schemas.openxmlformats.org/officeDocument/2006/relationships">
+<p:sld xmlns:a="http://schemas.openxmlformats.org/drawingml/2006/main" xmlns:r="http://schemas.openxmlformats.org/officeDocument/2006/relationships" xmlns:p="http://schemas.openxmlformats.org/presentationml/2006/main">
   <p:cSld>
     <p:bg>
       <p:bgPr>
@@ -9356,7 +9058,14 @@
         <p:cNvGrpSpPr/>
         <p:nvPr/>
       </p:nvGrpSpPr>
-      <p:grpSpPr/>
+      <p:grpSpPr>
+        <a:xfrm>
+          <a:off x="0" y="0"/>
+          <a:ext cx="0" cy="0"/>
+          <a:chOff x="0" y="0"/>
+          <a:chExt cx="0" cy="0"/>
+        </a:xfrm>
+      </p:grpSpPr>
       <p:sp>
         <p:nvSpPr>
           <p:cNvPr id="2" name="TextBox 1"/>
@@ -9510,6 +9219,7 @@
           <a:lstStyle/>
           <a:p>
             <a:pPr algn="ctr"/>
+            <a:endParaRPr/>
           </a:p>
         </p:txBody>
       </p:sp>
@@ -9554,6 +9264,7 @@
           <a:lstStyle/>
           <a:p>
             <a:pPr algn="ctr"/>
+            <a:endParaRPr/>
           </a:p>
         </p:txBody>
       </p:sp>
@@ -9597,6 +9308,7 @@
           <a:lstStyle/>
           <a:p>
             <a:pPr algn="ctr"/>
+            <a:endParaRPr/>
           </a:p>
         </p:txBody>
       </p:sp>
@@ -9746,6 +9458,7 @@
           <a:lstStyle/>
           <a:p>
             <a:pPr algn="ctr"/>
+            <a:endParaRPr/>
           </a:p>
         </p:txBody>
       </p:sp>
@@ -9789,6 +9502,7 @@
           <a:lstStyle/>
           <a:p>
             <a:pPr algn="ctr"/>
+            <a:endParaRPr/>
           </a:p>
         </p:txBody>
       </p:sp>
@@ -9938,6 +9652,7 @@
           <a:lstStyle/>
           <a:p>
             <a:pPr algn="ctr"/>
+            <a:endParaRPr/>
           </a:p>
         </p:txBody>
       </p:sp>
@@ -9981,6 +9696,7 @@
           <a:lstStyle/>
           <a:p>
             <a:pPr algn="ctr"/>
+            <a:endParaRPr/>
           </a:p>
         </p:txBody>
       </p:sp>
@@ -10122,7 +9838,7 @@
 </file>
 
 <file path=ppt/slides/slide5.xml><?xml version="1.0" encoding="utf-8"?>
-<p:sld xmlns:a="http://schemas.openxmlformats.org/drawingml/2006/main" xmlns:p="http://schemas.openxmlformats.org/presentationml/2006/main" xmlns:r="http://schemas.openxmlformats.org/officeDocument/2006/relationships">
+<p:sld xmlns:a="http://schemas.openxmlformats.org/drawingml/2006/main" xmlns:r="http://schemas.openxmlformats.org/officeDocument/2006/relationships" xmlns:p="http://schemas.openxmlformats.org/presentationml/2006/main">
   <p:cSld>
     <p:bg>
       <p:bgPr>
@@ -10138,7 +9854,14 @@
         <p:cNvGrpSpPr/>
         <p:nvPr/>
       </p:nvGrpSpPr>
-      <p:grpSpPr/>
+      <p:grpSpPr>
+        <a:xfrm>
+          <a:off x="0" y="0"/>
+          <a:ext cx="0" cy="0"/>
+          <a:chOff x="0" y="0"/>
+          <a:chExt cx="0" cy="0"/>
+        </a:xfrm>
+      </p:grpSpPr>
       <p:sp>
         <p:nvSpPr>
           <p:cNvPr id="2" name="TextBox 1"/>
@@ -10326,6 +10049,7 @@
           <a:lstStyle/>
           <a:p>
             <a:pPr algn="ctr"/>
+            <a:endParaRPr/>
           </a:p>
         </p:txBody>
       </p:sp>
@@ -10388,15 +10112,12 @@
                 <a:spcPts val="1200"/>
               </a:spcAft>
             </a:pPr>
-            <a:r>
-              <a:rPr sz="1600">
-                <a:solidFill>
-                  <a:srgbClr val="CBD5E1"/>
-                </a:solidFill>
-                <a:latin typeface="Inter"/>
-              </a:rPr>
-              <a:t/>
-            </a:r>
+            <a:endParaRPr sz="1600">
+              <a:solidFill>
+                <a:srgbClr val="CBD5E1"/>
+              </a:solidFill>
+              <a:latin typeface="Inter"/>
+            </a:endParaRPr>
           </a:p>
           <a:p>
             <a:pPr>
@@ -10481,7 +10202,7 @@
 </file>
 
 <file path=ppt/slides/slide6.xml><?xml version="1.0" encoding="utf-8"?>
-<p:sld xmlns:a="http://schemas.openxmlformats.org/drawingml/2006/main" xmlns:p="http://schemas.openxmlformats.org/presentationml/2006/main" xmlns:r="http://schemas.openxmlformats.org/officeDocument/2006/relationships">
+<p:sld xmlns:a="http://schemas.openxmlformats.org/drawingml/2006/main" xmlns:r="http://schemas.openxmlformats.org/officeDocument/2006/relationships" xmlns:p="http://schemas.openxmlformats.org/presentationml/2006/main">
   <p:cSld>
     <p:bg>
       <p:bgPr>
@@ -10497,7 +10218,14 @@
         <p:cNvGrpSpPr/>
         <p:nvPr/>
       </p:nvGrpSpPr>
-      <p:grpSpPr/>
+      <p:grpSpPr>
+        <a:xfrm>
+          <a:off x="0" y="0"/>
+          <a:ext cx="0" cy="0"/>
+          <a:chOff x="0" y="0"/>
+          <a:chExt cx="0" cy="0"/>
+        </a:xfrm>
+      </p:grpSpPr>
       <p:sp>
         <p:nvSpPr>
           <p:cNvPr id="2" name="TextBox 1"/>
@@ -10651,6 +10379,7 @@
           <a:lstStyle/>
           <a:p>
             <a:pPr algn="ctr"/>
+            <a:endParaRPr/>
           </a:p>
         </p:txBody>
       </p:sp>
@@ -10729,6 +10458,7 @@
           <a:lstStyle/>
           <a:p>
             <a:pPr algn="ctr"/>
+            <a:endParaRPr/>
           </a:p>
         </p:txBody>
       </p:sp>
@@ -10772,6 +10502,7 @@
           <a:lstStyle/>
           <a:p>
             <a:pPr algn="ctr"/>
+            <a:endParaRPr/>
           </a:p>
         </p:txBody>
       </p:sp>
@@ -10889,6 +10620,7 @@
           <a:lstStyle/>
           <a:p>
             <a:pPr algn="ctr"/>
+            <a:endParaRPr/>
           </a:p>
         </p:txBody>
       </p:sp>
@@ -10932,6 +10664,7 @@
           <a:lstStyle/>
           <a:p>
             <a:pPr algn="ctr"/>
+            <a:endParaRPr/>
           </a:p>
         </p:txBody>
       </p:sp>
@@ -11049,6 +10782,7 @@
           <a:lstStyle/>
           <a:p>
             <a:pPr algn="ctr"/>
+            <a:endParaRPr/>
           </a:p>
         </p:txBody>
       </p:sp>
@@ -11092,6 +10826,7 @@
           <a:lstStyle/>
           <a:p>
             <a:pPr algn="ctr"/>
+            <a:endParaRPr/>
           </a:p>
         </p:txBody>
       </p:sp>
@@ -11209,6 +10944,7 @@
           <a:lstStyle/>
           <a:p>
             <a:pPr algn="ctr"/>
+            <a:endParaRPr/>
           </a:p>
         </p:txBody>
       </p:sp>
@@ -11252,6 +10988,7 @@
           <a:lstStyle/>
           <a:p>
             <a:pPr algn="ctr"/>
+            <a:endParaRPr/>
           </a:p>
         </p:txBody>
       </p:sp>
@@ -11433,7 +11170,7 @@
 </file>
 
 <file path=ppt/slides/slide7.xml><?xml version="1.0" encoding="utf-8"?>
-<p:sld xmlns:a="http://schemas.openxmlformats.org/drawingml/2006/main" xmlns:p="http://schemas.openxmlformats.org/presentationml/2006/main" xmlns:r="http://schemas.openxmlformats.org/officeDocument/2006/relationships">
+<p:sld xmlns:a="http://schemas.openxmlformats.org/drawingml/2006/main" xmlns:r="http://schemas.openxmlformats.org/officeDocument/2006/relationships" xmlns:p="http://schemas.openxmlformats.org/presentationml/2006/main">
   <p:cSld>
     <p:bg>
       <p:bgPr>
@@ -11449,7 +11186,14 @@
         <p:cNvGrpSpPr/>
         <p:nvPr/>
       </p:nvGrpSpPr>
-      <p:grpSpPr/>
+      <p:grpSpPr>
+        <a:xfrm>
+          <a:off x="0" y="0"/>
+          <a:ext cx="0" cy="0"/>
+          <a:chOff x="0" y="0"/>
+          <a:chExt cx="0" cy="0"/>
+        </a:xfrm>
+      </p:grpSpPr>
       <p:sp>
         <p:nvSpPr>
           <p:cNvPr id="2" name="TextBox 1"/>
@@ -11603,6 +11347,7 @@
           <a:lstStyle/>
           <a:p>
             <a:pPr algn="ctr"/>
+            <a:endParaRPr/>
           </a:p>
         </p:txBody>
       </p:sp>
@@ -11681,6 +11426,7 @@
           <a:lstStyle/>
           <a:p>
             <a:pPr algn="ctr"/>
+            <a:endParaRPr/>
           </a:p>
         </p:txBody>
       </p:sp>
@@ -11724,6 +11470,7 @@
           <a:lstStyle/>
           <a:p>
             <a:pPr algn="ctr"/>
+            <a:endParaRPr/>
           </a:p>
         </p:txBody>
       </p:sp>
@@ -11884,15 +11631,12 @@
                 <a:spcPts val="600"/>
               </a:spcAft>
             </a:pPr>
-            <a:r>
-              <a:rPr sz="1200">
-                <a:solidFill>
-                  <a:srgbClr val="CBD5E1"/>
-                </a:solidFill>
-                <a:latin typeface="Inter"/>
-              </a:rPr>
-              <a:t/>
-            </a:r>
+            <a:endParaRPr sz="1200">
+              <a:solidFill>
+                <a:srgbClr val="CBD5E1"/>
+              </a:solidFill>
+              <a:latin typeface="Inter"/>
+            </a:endParaRPr>
           </a:p>
           <a:p>
             <a:pPr>
@@ -11969,6 +11713,7 @@
           <a:lstStyle/>
           <a:p>
             <a:pPr algn="ctr"/>
+            <a:endParaRPr/>
           </a:p>
         </p:txBody>
       </p:sp>
@@ -12012,6 +11757,7 @@
           <a:lstStyle/>
           <a:p>
             <a:pPr algn="ctr"/>
+            <a:endParaRPr/>
           </a:p>
         </p:txBody>
       </p:sp>
@@ -12108,15 +11854,12 @@
                 <a:spcPts val="600"/>
               </a:spcAft>
             </a:pPr>
-            <a:r>
-              <a:rPr sz="1200">
-                <a:solidFill>
-                  <a:srgbClr val="CBD5E1"/>
-                </a:solidFill>
-                <a:latin typeface="Inter"/>
-              </a:rPr>
-              <a:t/>
-            </a:r>
+            <a:endParaRPr sz="1200">
+              <a:solidFill>
+                <a:srgbClr val="CBD5E1"/>
+              </a:solidFill>
+              <a:latin typeface="Inter"/>
+            </a:endParaRPr>
           </a:p>
           <a:p>
             <a:pPr>
@@ -12156,15 +11899,12 @@
                 <a:spcPts val="600"/>
               </a:spcAft>
             </a:pPr>
-            <a:r>
-              <a:rPr sz="1200">
-                <a:solidFill>
-                  <a:srgbClr val="CBD5E1"/>
-                </a:solidFill>
-                <a:latin typeface="Inter"/>
-              </a:rPr>
-              <a:t/>
-            </a:r>
+            <a:endParaRPr sz="1200">
+              <a:solidFill>
+                <a:srgbClr val="CBD5E1"/>
+              </a:solidFill>
+              <a:latin typeface="Inter"/>
+            </a:endParaRPr>
           </a:p>
           <a:p>
             <a:pPr>
@@ -12241,6 +11981,7 @@
           <a:lstStyle/>
           <a:p>
             <a:pPr algn="ctr"/>
+            <a:endParaRPr/>
           </a:p>
         </p:txBody>
       </p:sp>
@@ -12284,6 +12025,7 @@
           <a:lstStyle/>
           <a:p>
             <a:pPr algn="ctr"/>
+            <a:endParaRPr/>
           </a:p>
         </p:txBody>
       </p:sp>
@@ -12380,15 +12122,12 @@
                 <a:spcPts val="600"/>
               </a:spcAft>
             </a:pPr>
-            <a:r>
-              <a:rPr sz="1200">
-                <a:solidFill>
-                  <a:srgbClr val="CBD5E1"/>
-                </a:solidFill>
-                <a:latin typeface="Inter"/>
-              </a:rPr>
-              <a:t/>
-            </a:r>
+            <a:endParaRPr sz="1200">
+              <a:solidFill>
+                <a:srgbClr val="CBD5E1"/>
+              </a:solidFill>
+              <a:latin typeface="Inter"/>
+            </a:endParaRPr>
           </a:p>
           <a:p>
             <a:pPr>
@@ -12428,15 +12167,12 @@
                 <a:spcPts val="600"/>
               </a:spcAft>
             </a:pPr>
-            <a:r>
-              <a:rPr sz="1200">
-                <a:solidFill>
-                  <a:srgbClr val="CBD5E1"/>
-                </a:solidFill>
-                <a:latin typeface="Inter"/>
-              </a:rPr>
-              <a:t/>
-            </a:r>
+            <a:endParaRPr sz="1200">
+              <a:solidFill>
+                <a:srgbClr val="CBD5E1"/>
+              </a:solidFill>
+              <a:latin typeface="Inter"/>
+            </a:endParaRPr>
           </a:p>
           <a:p>
             <a:pPr>
@@ -12481,7 +12217,7 @@
 </file>
 
 <file path=ppt/slides/slide8.xml><?xml version="1.0" encoding="utf-8"?>
-<p:sld xmlns:a="http://schemas.openxmlformats.org/drawingml/2006/main" xmlns:p="http://schemas.openxmlformats.org/presentationml/2006/main" xmlns:r="http://schemas.openxmlformats.org/officeDocument/2006/relationships">
+<p:sld xmlns:a="http://schemas.openxmlformats.org/drawingml/2006/main" xmlns:r="http://schemas.openxmlformats.org/officeDocument/2006/relationships" xmlns:p="http://schemas.openxmlformats.org/presentationml/2006/main">
   <p:cSld>
     <p:bg>
       <p:bgPr>
@@ -12497,7 +12233,14 @@
         <p:cNvGrpSpPr/>
         <p:nvPr/>
       </p:nvGrpSpPr>
-      <p:grpSpPr/>
+      <p:grpSpPr>
+        <a:xfrm>
+          <a:off x="0" y="0"/>
+          <a:ext cx="0" cy="0"/>
+          <a:chOff x="0" y="0"/>
+          <a:chExt cx="0" cy="0"/>
+        </a:xfrm>
+      </p:grpSpPr>
       <p:sp>
         <p:nvSpPr>
           <p:cNvPr id="2" name="TextBox 1"/>
@@ -12651,6 +12394,7 @@
           <a:lstStyle/>
           <a:p>
             <a:pPr algn="ctr"/>
+            <a:endParaRPr/>
           </a:p>
         </p:txBody>
       </p:sp>
@@ -12747,15 +12491,12 @@
                 <a:spcPts val="1200"/>
               </a:spcAft>
             </a:pPr>
-            <a:r>
-              <a:rPr sz="1700">
-                <a:solidFill>
-                  <a:srgbClr val="CBD5E1"/>
-                </a:solidFill>
-                <a:latin typeface="Inter"/>
-              </a:rPr>
-              <a:t/>
-            </a:r>
+            <a:endParaRPr sz="1700">
+              <a:solidFill>
+                <a:srgbClr val="CBD5E1"/>
+              </a:solidFill>
+              <a:latin typeface="Inter"/>
+            </a:endParaRPr>
           </a:p>
           <a:p>
             <a:pPr>
@@ -12795,15 +12536,12 @@
                 <a:spcPts val="1200"/>
               </a:spcAft>
             </a:pPr>
-            <a:r>
-              <a:rPr sz="1700">
-                <a:solidFill>
-                  <a:srgbClr val="CBD5E1"/>
-                </a:solidFill>
-                <a:latin typeface="Inter"/>
-              </a:rPr>
-              <a:t/>
-            </a:r>
+            <a:endParaRPr sz="1700">
+              <a:solidFill>
+                <a:srgbClr val="CBD5E1"/>
+              </a:solidFill>
+              <a:latin typeface="Inter"/>
+            </a:endParaRPr>
           </a:p>
           <a:p>
             <a:pPr>
@@ -12864,6 +12602,7 @@
           <a:lstStyle/>
           <a:p>
             <a:pPr algn="ctr"/>
+            <a:endParaRPr/>
           </a:p>
         </p:txBody>
       </p:sp>
@@ -12907,6 +12646,7 @@
           <a:lstStyle/>
           <a:p>
             <a:pPr algn="ctr"/>
+            <a:endParaRPr/>
           </a:p>
         </p:txBody>
       </p:sp>
@@ -13040,6 +12780,7 @@
           <a:lstStyle/>
           <a:p>
             <a:pPr algn="ctr"/>
+            <a:endParaRPr/>
           </a:p>
         </p:txBody>
       </p:sp>
@@ -13083,6 +12824,7 @@
           <a:lstStyle/>
           <a:p>
             <a:pPr algn="ctr"/>
+            <a:endParaRPr/>
           </a:p>
         </p:txBody>
       </p:sp>
@@ -13216,6 +12958,7 @@
           <a:lstStyle/>
           <a:p>
             <a:pPr algn="ctr"/>
+            <a:endParaRPr/>
           </a:p>
         </p:txBody>
       </p:sp>
@@ -13259,6 +13002,7 @@
           <a:lstStyle/>
           <a:p>
             <a:pPr algn="ctr"/>
+            <a:endParaRPr/>
           </a:p>
         </p:txBody>
       </p:sp>
@@ -13384,7 +13128,7 @@
 </file>
 
 <file path=ppt/slides/slide9.xml><?xml version="1.0" encoding="utf-8"?>
-<p:sld xmlns:a="http://schemas.openxmlformats.org/drawingml/2006/main" xmlns:p="http://schemas.openxmlformats.org/presentationml/2006/main" xmlns:r="http://schemas.openxmlformats.org/officeDocument/2006/relationships">
+<p:sld xmlns:a="http://schemas.openxmlformats.org/drawingml/2006/main" xmlns:r="http://schemas.openxmlformats.org/officeDocument/2006/relationships" xmlns:p="http://schemas.openxmlformats.org/presentationml/2006/main">
   <p:cSld>
     <p:bg>
       <p:bgPr>
@@ -13400,7 +13144,14 @@
         <p:cNvGrpSpPr/>
         <p:nvPr/>
       </p:nvGrpSpPr>
-      <p:grpSpPr/>
+      <p:grpSpPr>
+        <a:xfrm>
+          <a:off x="0" y="0"/>
+          <a:ext cx="0" cy="0"/>
+          <a:chOff x="0" y="0"/>
+          <a:chExt cx="0" cy="0"/>
+        </a:xfrm>
+      </p:grpSpPr>
       <p:sp>
         <p:nvSpPr>
           <p:cNvPr id="2" name="TextBox 1"/>
@@ -13554,6 +13305,7 @@
           <a:lstStyle/>
           <a:p>
             <a:pPr algn="ctr"/>
+            <a:endParaRPr/>
           </a:p>
         </p:txBody>
       </p:sp>
@@ -13598,6 +13350,7 @@
           <a:lstStyle/>
           <a:p>
             <a:pPr algn="ctr"/>
+            <a:endParaRPr/>
           </a:p>
         </p:txBody>
       </p:sp>
@@ -13641,6 +13394,7 @@
           <a:lstStyle/>
           <a:p>
             <a:pPr algn="ctr"/>
+            <a:endParaRPr/>
           </a:p>
         </p:txBody>
       </p:sp>
@@ -13721,15 +13475,12 @@
                 <a:spcPts val="600"/>
               </a:spcAft>
             </a:pPr>
-            <a:r>
-              <a:rPr sz="1200">
-                <a:solidFill>
-                  <a:srgbClr val="CBD5E1"/>
-                </a:solidFill>
-                <a:latin typeface="Inter"/>
-              </a:rPr>
-              <a:t/>
-            </a:r>
+            <a:endParaRPr sz="1200">
+              <a:solidFill>
+                <a:srgbClr val="CBD5E1"/>
+              </a:solidFill>
+              <a:latin typeface="Inter"/>
+            </a:endParaRPr>
           </a:p>
           <a:p>
             <a:pPr>
@@ -13785,15 +13536,12 @@
                 <a:spcPts val="600"/>
               </a:spcAft>
             </a:pPr>
-            <a:r>
-              <a:rPr sz="1200">
-                <a:solidFill>
-                  <a:srgbClr val="CBD5E1"/>
-                </a:solidFill>
-                <a:latin typeface="Inter"/>
-              </a:rPr>
-              <a:t/>
-            </a:r>
+            <a:endParaRPr sz="1200">
+              <a:solidFill>
+                <a:srgbClr val="CBD5E1"/>
+              </a:solidFill>
+              <a:latin typeface="Inter"/>
+            </a:endParaRPr>
           </a:p>
           <a:p>
             <a:pPr>
@@ -13870,6 +13618,7 @@
           <a:lstStyle/>
           <a:p>
             <a:pPr algn="ctr"/>
+            <a:endParaRPr/>
           </a:p>
         </p:txBody>
       </p:sp>
@@ -13913,6 +13662,7 @@
           <a:lstStyle/>
           <a:p>
             <a:pPr algn="ctr"/>
+            <a:endParaRPr/>
           </a:p>
         </p:txBody>
       </p:sp>
@@ -13993,15 +13743,12 @@
                 <a:spcPts val="600"/>
               </a:spcAft>
             </a:pPr>
-            <a:r>
-              <a:rPr sz="1200">
-                <a:solidFill>
-                  <a:srgbClr val="CBD5E1"/>
-                </a:solidFill>
-                <a:latin typeface="Inter"/>
-              </a:rPr>
-              <a:t/>
-            </a:r>
+            <a:endParaRPr sz="1200">
+              <a:solidFill>
+                <a:srgbClr val="CBD5E1"/>
+              </a:solidFill>
+              <a:latin typeface="Inter"/>
+            </a:endParaRPr>
           </a:p>
           <a:p>
             <a:pPr>
@@ -14057,15 +13804,12 @@
                 <a:spcPts val="600"/>
               </a:spcAft>
             </a:pPr>
-            <a:r>
-              <a:rPr sz="1200">
-                <a:solidFill>
-                  <a:srgbClr val="CBD5E1"/>
-                </a:solidFill>
-                <a:latin typeface="Inter"/>
-              </a:rPr>
-              <a:t/>
-            </a:r>
+            <a:endParaRPr sz="1200">
+              <a:solidFill>
+                <a:srgbClr val="CBD5E1"/>
+              </a:solidFill>
+              <a:latin typeface="Inter"/>
+            </a:endParaRPr>
           </a:p>
           <a:p>
             <a:pPr>
@@ -14158,6 +13902,7 @@
           <a:lstStyle/>
           <a:p>
             <a:pPr algn="ctr"/>
+            <a:endParaRPr/>
           </a:p>
         </p:txBody>
       </p:sp>
@@ -14201,6 +13946,7 @@
           <a:lstStyle/>
           <a:p>
             <a:pPr algn="ctr"/>
+            <a:endParaRPr/>
           </a:p>
         </p:txBody>
       </p:sp>
@@ -14297,15 +14043,12 @@
                 <a:spcPts val="600"/>
               </a:spcAft>
             </a:pPr>
-            <a:r>
-              <a:rPr sz="1200">
-                <a:solidFill>
-                  <a:srgbClr val="CBD5E1"/>
-                </a:solidFill>
-                <a:latin typeface="Inter"/>
-              </a:rPr>
-              <a:t/>
-            </a:r>
+            <a:endParaRPr sz="1200">
+              <a:solidFill>
+                <a:srgbClr val="CBD5E1"/>
+              </a:solidFill>
+              <a:latin typeface="Inter"/>
+            </a:endParaRPr>
           </a:p>
           <a:p>
             <a:pPr>
@@ -14345,15 +14088,12 @@
                 <a:spcPts val="600"/>
               </a:spcAft>
             </a:pPr>
-            <a:r>
-              <a:rPr sz="1200">
-                <a:solidFill>
-                  <a:srgbClr val="CBD5E1"/>
-                </a:solidFill>
-                <a:latin typeface="Inter"/>
-              </a:rPr>
-              <a:t/>
-            </a:r>
+            <a:endParaRPr sz="1200">
+              <a:solidFill>
+                <a:srgbClr val="CBD5E1"/>
+              </a:solidFill>
+              <a:latin typeface="Inter"/>
+            </a:endParaRPr>
           </a:p>
           <a:p>
             <a:pPr>
@@ -14744,44 +14484,44 @@
         <a:sysClr val="window" lastClr="FFFFFF"/>
       </a:lt1>
       <a:dk2>
-        <a:srgbClr val="1F497D"/>
+        <a:srgbClr val="0E2841"/>
       </a:dk2>
       <a:lt2>
-        <a:srgbClr val="EEECE1"/>
+        <a:srgbClr val="E8E8E8"/>
       </a:lt2>
       <a:accent1>
-        <a:srgbClr val="4F81BD"/>
+        <a:srgbClr val="156082"/>
       </a:accent1>
       <a:accent2>
-        <a:srgbClr val="C0504D"/>
+        <a:srgbClr val="E97132"/>
       </a:accent2>
       <a:accent3>
-        <a:srgbClr val="9BBB59"/>
+        <a:srgbClr val="196B24"/>
       </a:accent3>
       <a:accent4>
-        <a:srgbClr val="8064A2"/>
+        <a:srgbClr val="0F9ED5"/>
       </a:accent4>
       <a:accent5>
-        <a:srgbClr val="4BACC6"/>
+        <a:srgbClr val="A02B93"/>
       </a:accent5>
       <a:accent6>
-        <a:srgbClr val="F79646"/>
+        <a:srgbClr val="4EA72E"/>
       </a:accent6>
       <a:hlink>
-        <a:srgbClr val="0000FF"/>
+        <a:srgbClr val="467886"/>
       </a:hlink>
       <a:folHlink>
-        <a:srgbClr val="800080"/>
+        <a:srgbClr val="96607D"/>
       </a:folHlink>
     </a:clrScheme>
     <a:fontScheme name="Office">
       <a:majorFont>
-        <a:latin typeface="Calibri"/>
+        <a:latin typeface="Aptos Display" panose="02110004020202020204"/>
         <a:ea typeface=""/>
         <a:cs typeface=""/>
-        <a:font script="Jpan" typeface="ＭＳ Ｐゴシック"/>
+        <a:font script="Jpan" typeface="游ゴシック Light"/>
         <a:font script="Hang" typeface="맑은 고딕"/>
-        <a:font script="Hans" typeface="宋体"/>
+        <a:font script="Hans" typeface="等线 Light"/>
         <a:font script="Hant" typeface="新細明體"/>
         <a:font script="Arab" typeface="Times New Roman"/>
         <a:font script="Hebr" typeface="Times New Roman"/>
@@ -14809,14 +14549,31 @@
         <a:font script="Viet" typeface="Times New Roman"/>
         <a:font script="Uigh" typeface="Microsoft Uighur"/>
         <a:font script="Geor" typeface="Sylfaen"/>
+        <a:font script="Armn" typeface="Arial"/>
+        <a:font script="Bugi" typeface="Leelawadee UI"/>
+        <a:font script="Bopo" typeface="Microsoft JhengHei"/>
+        <a:font script="Java" typeface="Javanese Text"/>
+        <a:font script="Lisu" typeface="Segoe UI"/>
+        <a:font script="Mymr" typeface="Myanmar Text"/>
+        <a:font script="Nkoo" typeface="Ebrima"/>
+        <a:font script="Olck" typeface="Nirmala UI"/>
+        <a:font script="Osma" typeface="Ebrima"/>
+        <a:font script="Phag" typeface="Phagspa"/>
+        <a:font script="Syrn" typeface="Estrangelo Edessa"/>
+        <a:font script="Syrj" typeface="Estrangelo Edessa"/>
+        <a:font script="Syre" typeface="Estrangelo Edessa"/>
+        <a:font script="Sora" typeface="Nirmala UI"/>
+        <a:font script="Tale" typeface="Microsoft Tai Le"/>
+        <a:font script="Talu" typeface="Microsoft New Tai Lue"/>
+        <a:font script="Tfng" typeface="Ebrima"/>
       </a:majorFont>
       <a:minorFont>
-        <a:latin typeface="Calibri"/>
+        <a:latin typeface="Aptos" panose="02110004020202020204"/>
         <a:ea typeface=""/>
         <a:cs typeface=""/>
-        <a:font script="Jpan" typeface="ＭＳ Ｐゴシック"/>
+        <a:font script="Jpan" typeface="游ゴシック"/>
         <a:font script="Hang" typeface="맑은 고딕"/>
-        <a:font script="Hans" typeface="宋体"/>
+        <a:font script="Hans" typeface="等线"/>
         <a:font script="Hant" typeface="新細明體"/>
         <a:font script="Arab" typeface="Arial"/>
         <a:font script="Hebr" typeface="Arial"/>
@@ -14844,6 +14601,23 @@
         <a:font script="Viet" typeface="Arial"/>
         <a:font script="Uigh" typeface="Microsoft Uighur"/>
         <a:font script="Geor" typeface="Sylfaen"/>
+        <a:font script="Armn" typeface="Arial"/>
+        <a:font script="Bugi" typeface="Leelawadee UI"/>
+        <a:font script="Bopo" typeface="Microsoft JhengHei"/>
+        <a:font script="Java" typeface="Javanese Text"/>
+        <a:font script="Lisu" typeface="Segoe UI"/>
+        <a:font script="Mymr" typeface="Myanmar Text"/>
+        <a:font script="Nkoo" typeface="Ebrima"/>
+        <a:font script="Olck" typeface="Nirmala UI"/>
+        <a:font script="Osma" typeface="Ebrima"/>
+        <a:font script="Phag" typeface="Phagspa"/>
+        <a:font script="Syrn" typeface="Estrangelo Edessa"/>
+        <a:font script="Syrj" typeface="Estrangelo Edessa"/>
+        <a:font script="Syre" typeface="Estrangelo Edessa"/>
+        <a:font script="Sora" typeface="Nirmala UI"/>
+        <a:font script="Tale" typeface="Microsoft Tai Le"/>
+        <a:font script="Talu" typeface="Microsoft New Tai Lue"/>
+        <a:font script="Tfng" typeface="Ebrima"/>
       </a:minorFont>
     </a:fontScheme>
     <a:fmtScheme name="Office">
@@ -14855,180 +14629,136 @@
           <a:gsLst>
             <a:gs pos="0">
               <a:schemeClr val="phClr">
-                <a:tint val="50000"/>
-                <a:satMod val="300000"/>
+                <a:lumMod val="110000"/>
+                <a:satMod val="105000"/>
+                <a:tint val="67000"/>
               </a:schemeClr>
             </a:gs>
-            <a:gs pos="35000">
+            <a:gs pos="50000">
               <a:schemeClr val="phClr">
-                <a:tint val="37000"/>
-                <a:satMod val="300000"/>
+                <a:lumMod val="105000"/>
+                <a:satMod val="103000"/>
+                <a:tint val="73000"/>
               </a:schemeClr>
             </a:gs>
             <a:gs pos="100000">
               <a:schemeClr val="phClr">
-                <a:tint val="15000"/>
-                <a:satMod val="350000"/>
+                <a:lumMod val="105000"/>
+                <a:satMod val="109000"/>
+                <a:tint val="81000"/>
               </a:schemeClr>
             </a:gs>
           </a:gsLst>
-          <a:lin ang="16200000" scaled="1"/>
+          <a:lin ang="5400000" scaled="0"/>
         </a:gradFill>
         <a:gradFill rotWithShape="1">
           <a:gsLst>
             <a:gs pos="0">
               <a:schemeClr val="phClr">
-                <a:tint val="100000"/>
+                <a:satMod val="103000"/>
+                <a:lumMod val="102000"/>
+                <a:tint val="94000"/>
+              </a:schemeClr>
+            </a:gs>
+            <a:gs pos="50000">
+              <a:schemeClr val="phClr">
+                <a:satMod val="110000"/>
+                <a:lumMod val="100000"/>
                 <a:shade val="100000"/>
-                <a:satMod val="130000"/>
               </a:schemeClr>
             </a:gs>
             <a:gs pos="100000">
               <a:schemeClr val="phClr">
-                <a:tint val="50000"/>
-                <a:shade val="100000"/>
-                <a:satMod val="350000"/>
+                <a:lumMod val="99000"/>
+                <a:satMod val="120000"/>
+                <a:shade val="78000"/>
               </a:schemeClr>
             </a:gs>
           </a:gsLst>
-          <a:lin ang="16200000" scaled="0"/>
+          <a:lin ang="5400000" scaled="0"/>
         </a:gradFill>
       </a:fillStyleLst>
       <a:lnStyleLst>
-        <a:ln w="9525" cap="flat" cmpd="sng" algn="ctr">
+        <a:ln w="12700" cap="flat" cmpd="sng" algn="ctr">
           <a:solidFill>
-            <a:schemeClr val="phClr">
-              <a:shade val="95000"/>
-              <a:satMod val="105000"/>
-            </a:schemeClr>
+            <a:schemeClr val="phClr"/>
           </a:solidFill>
           <a:prstDash val="solid"/>
+          <a:miter lim="800000"/>
+        </a:ln>
+        <a:ln w="19050" cap="flat" cmpd="sng" algn="ctr">
+          <a:solidFill>
+            <a:schemeClr val="phClr"/>
+          </a:solidFill>
+          <a:prstDash val="solid"/>
+          <a:miter lim="800000"/>
         </a:ln>
         <a:ln w="25400" cap="flat" cmpd="sng" algn="ctr">
           <a:solidFill>
             <a:schemeClr val="phClr"/>
           </a:solidFill>
           <a:prstDash val="solid"/>
-        </a:ln>
-        <a:ln w="38100" cap="flat" cmpd="sng" algn="ctr">
-          <a:solidFill>
-            <a:schemeClr val="phClr"/>
-          </a:solidFill>
-          <a:prstDash val="solid"/>
+          <a:miter lim="800000"/>
         </a:ln>
       </a:lnStyleLst>
       <a:effectStyleLst>
         <a:effectStyle>
+          <a:effectLst/>
+        </a:effectStyle>
+        <a:effectStyle>
+          <a:effectLst/>
+        </a:effectStyle>
+        <a:effectStyle>
           <a:effectLst>
-            <a:outerShdw blurRad="40000" dist="20000" dir="5400000" rotWithShape="0">
+            <a:outerShdw blurRad="57150" dist="19050" dir="5400000" algn="ctr" rotWithShape="0">
               <a:srgbClr val="000000">
-                <a:alpha val="38000"/>
+                <a:alpha val="63000"/>
               </a:srgbClr>
             </a:outerShdw>
           </a:effectLst>
-        </a:effectStyle>
-        <a:effectStyle>
-          <a:effectLst>
-            <a:outerShdw blurRad="40000" dist="23000" dir="5400000" rotWithShape="0">
-              <a:srgbClr val="000000">
-                <a:alpha val="35000"/>
-              </a:srgbClr>
-            </a:outerShdw>
-          </a:effectLst>
-        </a:effectStyle>
-        <a:effectStyle>
-          <a:effectLst>
-            <a:outerShdw blurRad="40000" dist="23000" dir="5400000" rotWithShape="0">
-              <a:srgbClr val="000000">
-                <a:alpha val="35000"/>
-              </a:srgbClr>
-            </a:outerShdw>
-          </a:effectLst>
-          <a:scene3d>
-            <a:camera prst="orthographicFront">
-              <a:rot lat="0" lon="0" rev="0"/>
-            </a:camera>
-            <a:lightRig rig="threePt" dir="t">
-              <a:rot lat="0" lon="0" rev="1200000"/>
-            </a:lightRig>
-          </a:scene3d>
-          <a:sp3d>
-            <a:bevelT w="63500" h="25400"/>
-          </a:sp3d>
         </a:effectStyle>
       </a:effectStyleLst>
       <a:bgFillStyleLst>
         <a:solidFill>
           <a:schemeClr val="phClr"/>
         </a:solidFill>
+        <a:solidFill>
+          <a:schemeClr val="phClr">
+            <a:tint val="95000"/>
+            <a:satMod val="170000"/>
+          </a:schemeClr>
+        </a:solidFill>
         <a:gradFill rotWithShape="1">
           <a:gsLst>
             <a:gs pos="0">
               <a:schemeClr val="phClr">
-                <a:tint val="40000"/>
-                <a:satMod val="350000"/>
+                <a:tint val="93000"/>
+                <a:satMod val="150000"/>
+                <a:shade val="98000"/>
+                <a:lumMod val="102000"/>
               </a:schemeClr>
             </a:gs>
-            <a:gs pos="40000">
+            <a:gs pos="50000">
               <a:schemeClr val="phClr">
-                <a:tint val="45000"/>
-                <a:shade val="99000"/>
-                <a:satMod val="350000"/>
+                <a:tint val="98000"/>
+                <a:satMod val="130000"/>
+                <a:shade val="90000"/>
+                <a:lumMod val="103000"/>
               </a:schemeClr>
             </a:gs>
             <a:gs pos="100000">
               <a:schemeClr val="phClr">
-                <a:shade val="20000"/>
-                <a:satMod val="255000"/>
+                <a:shade val="63000"/>
+                <a:satMod val="120000"/>
               </a:schemeClr>
             </a:gs>
           </a:gsLst>
-          <a:path path="circle">
-            <a:fillToRect l="50000" t="-80000" r="50000" b="180000"/>
-          </a:path>
-        </a:gradFill>
-        <a:gradFill rotWithShape="1">
-          <a:gsLst>
-            <a:gs pos="0">
-              <a:schemeClr val="phClr">
-                <a:tint val="80000"/>
-                <a:satMod val="300000"/>
-              </a:schemeClr>
-            </a:gs>
-            <a:gs pos="100000">
-              <a:schemeClr val="phClr">
-                <a:shade val="30000"/>
-                <a:satMod val="200000"/>
-              </a:schemeClr>
-            </a:gs>
-          </a:gsLst>
-          <a:path path="circle">
-            <a:fillToRect l="50000" t="50000" r="50000" b="50000"/>
-          </a:path>
+          <a:lin ang="5400000" scaled="0"/>
         </a:gradFill>
       </a:bgFillStyleLst>
     </a:fmtScheme>
   </a:themeElements>
   <a:objectDefaults>
-    <a:spDef>
-      <a:spPr/>
-      <a:bodyPr/>
-      <a:lstStyle/>
-      <a:style>
-        <a:lnRef idx="1">
-          <a:schemeClr val="accent1"/>
-        </a:lnRef>
-        <a:fillRef idx="3">
-          <a:schemeClr val="accent1"/>
-        </a:fillRef>
-        <a:effectRef idx="2">
-          <a:schemeClr val="accent1"/>
-        </a:effectRef>
-        <a:fontRef idx="minor">
-          <a:schemeClr val="lt1"/>
-        </a:fontRef>
-      </a:style>
-    </a:spDef>
     <a:lnDef>
       <a:spPr/>
       <a:bodyPr/>
@@ -15050,5 +14780,10 @@
     </a:lnDef>
   </a:objectDefaults>
   <a:extraClrSchemeLst/>
+  <a:extLst>
+    <a:ext uri="{05A4C25C-085E-4340-85A3-A5531E510DB2}">
+      <thm15:themeFamily xmlns:thm15="http://schemas.microsoft.com/office/thememl/2012/main" name="Office Theme" id="{2E142A2C-CD16-42D6-873A-C26D2A0506FA}" vid="{1BDDFF52-6CD6-40A5-AB3C-68EB2F1E4D0A}"/>
+    </a:ext>
+  </a:extLst>
 </a:theme>
 </file>
</xml_diff>